<commit_message>
Lesson sd-10-008: match the deck and its PPTX to the rewritten lesson
Co-Authored-By: Claude Sonnet 5.5 <noreply@anthropic.com>
Claude-Session: https://claude.ai/code/session_01Y9NYFwg4CcDYEWi1zr53gi
</commit_message>
<xml_diff>
--- a/system-design-101/vi/lessons/sd-10-008/slides/sd-10-008.pptx
+++ b/system-design-101/vi/lessons/sd-10-008/slides/sd-10-008.pptx
@@ -4286,7 +4286,7 @@
               <a:buNone/>
             </a:pPr>
             <a:r>
-              <a:rPr lang="en-US" sz="3900" dirty="0" spc="-2" kern="0">
+              <a:rPr lang="en-US" sz="3900" dirty="0" spc="-17" kern="0">
                 <a:solidFill>
                   <a:srgbClr val="7C93FF"/>
                 </a:solidFill>
@@ -4294,18 +4294,7 @@
                 <a:ea typeface="Bricolage Grotesque ExtraBold" pitchFamily="34" charset="-122"/>
                 <a:cs typeface="Bricolage Grotesque ExtraBold" pitchFamily="34" charset="-120"/>
               </a:rPr>
-              <a:t>Bộ</a:t>
-            </a:r>
-            <a:r>
-              <a:rPr lang="en-US" sz="3900" dirty="0" spc="11" kern="0">
-                <a:solidFill>
-                  <a:srgbClr val="7C93FF"/>
-                </a:solidFill>
-                <a:latin typeface="Bricolage Grotesque ExtraBold" pitchFamily="34" charset="0"/>
-                <a:ea typeface="Bricolage Grotesque ExtraBold" pitchFamily="34" charset="-122"/>
-                <a:cs typeface="Bricolage Grotesque ExtraBold" pitchFamily="34" charset="-120"/>
-              </a:rPr>
-              <a:t> đệm</a:t>
+              <a:t>Future</a:t>
             </a:r>
             <a:endParaRPr lang="en-US" sz="3900" dirty="0"/>
           </a:p>
@@ -4339,6 +4328,83 @@
               <a:buNone/>
             </a:pPr>
             <a:r>
+              <a:rPr lang="en-US" sz="2250" dirty="0" spc="-5" kern="0">
+                <a:solidFill>
+                  <a:srgbClr val="F3EEE3"/>
+                </a:solidFill>
+                <a:latin typeface="Be Vietnam Pro" pitchFamily="34" charset="0"/>
+                <a:ea typeface="Be Vietnam Pro" pitchFamily="34" charset="-122"/>
+                <a:cs typeface="Be Vietnam Pro" pitchFamily="34" charset="-120"/>
+              </a:rPr>
+              <a:t>Đại</a:t>
+            </a:r>
+            <a:r>
+              <a:rPr lang="en-US" sz="2250" dirty="0" spc="0" kern="0">
+                <a:solidFill>
+                  <a:srgbClr val="F3EEE3"/>
+                </a:solidFill>
+                <a:latin typeface="Be Vietnam Pro" pitchFamily="34" charset="0"/>
+                <a:ea typeface="Be Vietnam Pro" pitchFamily="34" charset="-122"/>
+                <a:cs typeface="Be Vietnam Pro" pitchFamily="34" charset="-120"/>
+              </a:rPr>
+              <a:t> diện</a:t>
+            </a:r>
+            <a:r>
+              <a:rPr lang="en-US" sz="2250" dirty="0" spc="1" kern="0">
+                <a:solidFill>
+                  <a:srgbClr val="F3EEE3"/>
+                </a:solidFill>
+                <a:latin typeface="Be Vietnam Pro" pitchFamily="34" charset="0"/>
+                <a:ea typeface="Be Vietnam Pro" pitchFamily="34" charset="-122"/>
+                <a:cs typeface="Be Vietnam Pro" pitchFamily="34" charset="-120"/>
+              </a:rPr>
+              <a:t> cho</a:t>
+            </a:r>
+            <a:r>
+              <a:rPr lang="en-US" sz="2250" dirty="0" spc="-31" kern="0">
+                <a:solidFill>
+                  <a:srgbClr val="F3EEE3"/>
+                </a:solidFill>
+                <a:latin typeface="Be Vietnam Pro" pitchFamily="34" charset="0"/>
+                <a:ea typeface="Be Vietnam Pro" pitchFamily="34" charset="-122"/>
+                <a:cs typeface="Be Vietnam Pro" pitchFamily="34" charset="-120"/>
+              </a:rPr>
+              <a:t> kết</a:t>
+            </a:r>
+            <a:r>
+              <a:rPr lang="en-US" sz="2250" dirty="0" spc="1" kern="0">
+                <a:solidFill>
+                  <a:srgbClr val="F3EEE3"/>
+                </a:solidFill>
+                <a:latin typeface="Be Vietnam Pro" pitchFamily="34" charset="0"/>
+                <a:ea typeface="Be Vietnam Pro" pitchFamily="34" charset="-122"/>
+                <a:cs typeface="Be Vietnam Pro" pitchFamily="34" charset="-120"/>
+              </a:rPr>
+              <a:t> quả</a:t>
+            </a:r>
+            <a:r>
+              <a:rPr lang="en-US" sz="2250" dirty="0" spc="2" kern="0">
+                <a:solidFill>
+                  <a:srgbClr val="F3EEE3"/>
+                </a:solidFill>
+                <a:latin typeface="Be Vietnam Pro" pitchFamily="34" charset="0"/>
+                <a:ea typeface="Be Vietnam Pro" pitchFamily="34" charset="-122"/>
+                <a:cs typeface="Be Vietnam Pro" pitchFamily="34" charset="-120"/>
+              </a:rPr>
+              <a:t> của</a:t>
+            </a:r>
+            <a:r>
+              <a:rPr lang="en-US" sz="2250" dirty="0" spc="-4" kern="0">
+                <a:solidFill>
+                  <a:srgbClr val="F3EEE3"/>
+                </a:solidFill>
+                <a:latin typeface="Be Vietnam Pro" pitchFamily="34" charset="0"/>
+                <a:ea typeface="Be Vietnam Pro" pitchFamily="34" charset="-122"/>
+                <a:cs typeface="Be Vietnam Pro" pitchFamily="34" charset="-120"/>
+              </a:rPr>
+              <a:t> một</a:t>
+            </a:r>
+            <a:r>
               <a:rPr lang="en-US" sz="2250" dirty="0" spc="-3" kern="0">
                 <a:solidFill>
                   <a:srgbClr val="F3EEE3"/>
@@ -4347,117 +4413,29 @@
                 <a:ea typeface="Be Vietnam Pro" pitchFamily="34" charset="-122"/>
                 <a:cs typeface="Be Vietnam Pro" pitchFamily="34" charset="-120"/>
               </a:rPr>
-              <a:t>Hàng</a:t>
-            </a:r>
-            <a:r>
-              <a:rPr lang="en-US" sz="2250" dirty="0" spc="13" kern="0">
-                <a:solidFill>
-                  <a:srgbClr val="F3EEE3"/>
-                </a:solidFill>
-                <a:latin typeface="Be Vietnam Pro" pitchFamily="34" charset="0"/>
-                <a:ea typeface="Be Vietnam Pro" pitchFamily="34" charset="-122"/>
-                <a:cs typeface="Be Vietnam Pro" pitchFamily="34" charset="-120"/>
-              </a:rPr>
-              <a:t> đợi</a:t>
-            </a:r>
-            <a:r>
-              <a:rPr lang="en-US" sz="2250" dirty="0" spc="1" kern="0">
-                <a:solidFill>
-                  <a:srgbClr val="F3EEE3"/>
-                </a:solidFill>
-                <a:latin typeface="Be Vietnam Pro" pitchFamily="34" charset="0"/>
-                <a:ea typeface="Be Vietnam Pro" pitchFamily="34" charset="-122"/>
-                <a:cs typeface="Be Vietnam Pro" pitchFamily="34" charset="-120"/>
-              </a:rPr>
-              <a:t> chặn</a:t>
-            </a:r>
-            <a:r>
-              <a:rPr lang="en-US" sz="2250" dirty="0" spc="20" kern="0">
-                <a:solidFill>
-                  <a:srgbClr val="F3EEE3"/>
-                </a:solidFill>
-                <a:latin typeface="Be Vietnam Pro" pitchFamily="34" charset="0"/>
-                <a:ea typeface="Be Vietnam Pro" pitchFamily="34" charset="-122"/>
-                <a:cs typeface="Be Vietnam Pro" pitchFamily="34" charset="-120"/>
-              </a:rPr>
-              <a:t> đứng</a:t>
-            </a:r>
-            <a:r>
-              <a:rPr lang="en-US" sz="2250" dirty="0" spc="5" kern="0">
-                <a:solidFill>
-                  <a:srgbClr val="F3EEE3"/>
-                </a:solidFill>
-                <a:latin typeface="Be Vietnam Pro" pitchFamily="34" charset="0"/>
-                <a:ea typeface="Be Vietnam Pro" pitchFamily="34" charset="-122"/>
-                <a:cs typeface="Be Vietnam Pro" pitchFamily="34" charset="-120"/>
-              </a:rPr>
-              <a:t> giữa</a:t>
-            </a:r>
-            <a:r>
-              <a:rPr lang="en-US" sz="2250" dirty="0" spc="1" kern="0">
-                <a:solidFill>
-                  <a:srgbClr val="F3EEE3"/>
-                </a:solidFill>
-                <a:latin typeface="Be Vietnam Pro" pitchFamily="34" charset="0"/>
-                <a:ea typeface="Be Vietnam Pro" pitchFamily="34" charset="-122"/>
-                <a:cs typeface="Be Vietnam Pro" pitchFamily="34" charset="-120"/>
-              </a:rPr>
-              <a:t> luồng</a:t>
-            </a:r>
-            <a:r>
-              <a:rPr lang="en-US" sz="2250" dirty="0" spc="-4" kern="0">
-                <a:solidFill>
-                  <a:srgbClr val="F3EEE3"/>
-                </a:solidFill>
-                <a:latin typeface="Be Vietnam Pro" pitchFamily="34" charset="0"/>
-                <a:ea typeface="Be Vietnam Pro" pitchFamily="34" charset="-122"/>
-                <a:cs typeface="Be Vietnam Pro" pitchFamily="34" charset="-120"/>
-              </a:rPr>
-              <a:t> sản</a:t>
-            </a:r>
-            <a:r>
-              <a:rPr lang="en-US" sz="2250" dirty="0" spc="-10" kern="0">
-                <a:solidFill>
-                  <a:srgbClr val="F3EEE3"/>
-                </a:solidFill>
-                <a:latin typeface="Be Vietnam Pro" pitchFamily="34" charset="0"/>
-                <a:ea typeface="Be Vietnam Pro" pitchFamily="34" charset="-122"/>
-                <a:cs typeface="Be Vietnam Pro" pitchFamily="34" charset="-120"/>
-              </a:rPr>
-              <a:t> xuất</a:t>
-            </a:r>
-            <a:r>
-              <a:rPr lang="en-US" sz="2250" dirty="0" spc="-17" kern="0">
-                <a:solidFill>
-                  <a:srgbClr val="F3EEE3"/>
-                </a:solidFill>
-                <a:latin typeface="Be Vietnam Pro" pitchFamily="34" charset="0"/>
-                <a:ea typeface="Be Vietnam Pro" pitchFamily="34" charset="-122"/>
-                <a:cs typeface="Be Vietnam Pro" pitchFamily="34" charset="-120"/>
-              </a:rPr>
-              <a:t> và</a:t>
-            </a:r>
-            <a:r>
-              <a:rPr lang="en-US" sz="2250" dirty="0" spc="-1" kern="0">
-                <a:solidFill>
-                  <a:srgbClr val="F3EEE3"/>
-                </a:solidFill>
-                <a:latin typeface="Be Vietnam Pro" pitchFamily="34" charset="0"/>
-                <a:ea typeface="Be Vietnam Pro" pitchFamily="34" charset="-122"/>
-                <a:cs typeface="Be Vietnam Pro" pitchFamily="34" charset="-120"/>
-              </a:rPr>
-              <a:t> tiêu</a:t>
-            </a:r>
-            <a:r>
-              <a:rPr lang="en-US" sz="2250" dirty="0" spc="3" kern="0">
-                <a:solidFill>
-                  <a:srgbClr val="F3EEE3"/>
-                </a:solidFill>
-                <a:latin typeface="Be Vietnam Pro" pitchFamily="34" charset="0"/>
-                <a:ea typeface="Be Vietnam Pro" pitchFamily="34" charset="-122"/>
-                <a:cs typeface="Be Vietnam Pro" pitchFamily="34" charset="-120"/>
-              </a:rPr>
-              <a:t> thụ.</a:t>
+              <a:t> việc</a:t>
+            </a:r>
+            <a:r>
+              <a:rPr lang="en-US" sz="2250" dirty="0" spc="9" kern="0">
+                <a:solidFill>
+                  <a:srgbClr val="F3EEE3"/>
+                </a:solidFill>
+                <a:latin typeface="Be Vietnam Pro" pitchFamily="34" charset="0"/>
+                <a:ea typeface="Be Vietnam Pro" pitchFamily="34" charset="-122"/>
+                <a:cs typeface="Be Vietnam Pro" pitchFamily="34" charset="-120"/>
+              </a:rPr>
+              <a:t> đang</a:t>
+            </a:r>
+            <a:r>
+              <a:rPr lang="en-US" sz="2250" dirty="0" spc="-5" kern="0">
+                <a:solidFill>
+                  <a:srgbClr val="F3EEE3"/>
+                </a:solidFill>
+                <a:latin typeface="Be Vietnam Pro" pitchFamily="34" charset="0"/>
+                <a:ea typeface="Be Vietnam Pro" pitchFamily="34" charset="-122"/>
+                <a:cs typeface="Be Vietnam Pro" pitchFamily="34" charset="-120"/>
+              </a:rPr>
+              <a:t> chạy.</a:t>
             </a:r>
             <a:endParaRPr lang="en-US" sz="2250" dirty="0"/>
           </a:p>
@@ -4624,7 +4602,7 @@
               <a:buNone/>
             </a:pPr>
             <a:r>
-              <a:rPr lang="en-US" sz="1950" dirty="0" spc="-5" kern="0">
+              <a:rPr lang="en-US" sz="1950" dirty="0" spc="-2" kern="0">
                 <a:solidFill>
                   <a:srgbClr val="C4C8D6"/>
                 </a:solidFill>
@@ -4632,10 +4610,10 @@
                 <a:ea typeface="Be Vietnam Pro" pitchFamily="34" charset="-122"/>
                 <a:cs typeface="Be Vietnam Pro" pitchFamily="34" charset="-120"/>
               </a:rPr>
-              <a:t>system-design-101:</a:t>
-            </a:r>
-            <a:r>
-              <a:rPr lang="en-US" sz="1950" dirty="0" spc="14" kern="0">
+              <a:t>chỉ</a:t>
+            </a:r>
+            <a:r>
+              <a:rPr lang="en-US" sz="1950" dirty="0" spc="-9" kern="0">
                 <a:solidFill>
                   <a:srgbClr val="C4C8D6"/>
                 </a:solidFill>
@@ -4643,7 +4621,18 @@
                 <a:ea typeface="Be Vietnam Pro" pitchFamily="34" charset="-122"/>
                 <a:cs typeface="Be Vietnam Pro" pitchFamily="34" charset="-120"/>
               </a:rPr>
-              <a:t> đa</a:t>
+              <a:t> lấy tên</a:t>
+            </a:r>
+            <a:r>
+              <a:rPr lang="en-US" sz="1950" dirty="0" spc="-4" kern="0">
+                <a:solidFill>
+                  <a:srgbClr val="C4C8D6"/>
+                </a:solidFill>
+                <a:latin typeface="Be Vietnam Pro" pitchFamily="34" charset="0"/>
+                <a:ea typeface="Be Vietnam Pro" pitchFamily="34" charset="-122"/>
+                <a:cs typeface="Be Vietnam Pro" pitchFamily="34" charset="-120"/>
+              </a:rPr>
+              <a:t> sáu</a:t>
             </a:r>
             <a:r>
               <a:rPr lang="en-US" sz="1950" dirty="0" spc="1" kern="0">
@@ -4654,62 +4643,7 @@
                 <a:ea typeface="Be Vietnam Pro" pitchFamily="34" charset="-122"/>
                 <a:cs typeface="Be Vietnam Pro" pitchFamily="34" charset="-120"/>
               </a:rPr>
-              <a:t> luồng</a:t>
-            </a:r>
-            <a:r>
-              <a:rPr lang="en-US" sz="1950" dirty="0" spc="-15" kern="0">
-                <a:solidFill>
-                  <a:srgbClr val="C4C8D6"/>
-                </a:solidFill>
-                <a:latin typeface="Be Vietnam Pro" pitchFamily="34" charset="0"/>
-                <a:ea typeface="Be Vietnam Pro" pitchFamily="34" charset="-122"/>
-                <a:cs typeface="Be Vietnam Pro" pitchFamily="34" charset="-120"/>
-              </a:rPr>
-              <a:t> và</a:t>
-            </a:r>
-            <a:r>
-              <a:rPr lang="en-US" sz="1950" dirty="0" spc="-4" kern="0">
-                <a:solidFill>
-                  <a:srgbClr val="C4C8D6"/>
-                </a:solidFill>
-                <a:latin typeface="Be Vietnam Pro" pitchFamily="34" charset="0"/>
-                <a:ea typeface="Be Vietnam Pro" pitchFamily="34" charset="-122"/>
-                <a:cs typeface="Be Vietnam Pro" pitchFamily="34" charset="-120"/>
-              </a:rPr>
-              <a:t> sáu</a:t>
-            </a:r>
-            <a:r>
-              <a:rPr lang="en-US" sz="1950" dirty="0" spc="1" kern="0">
-                <a:solidFill>
-                  <a:srgbClr val="C4C8D6"/>
-                </a:solidFill>
-                <a:latin typeface="Be Vietnam Pro" pitchFamily="34" charset="0"/>
-                <a:ea typeface="Be Vietnam Pro" pitchFamily="34" charset="-122"/>
-                <a:cs typeface="Be Vietnam Pro" pitchFamily="34" charset="-120"/>
-              </a:rPr>
               <a:t> mẫu</a:t>
-            </a:r>
-            <a:r>
-              <a:rPr lang="en-US" sz="1950" dirty="0" spc="-4" kern="0">
-                <a:solidFill>
-                  <a:srgbClr val="C4C8D6"/>
-                </a:solidFill>
-                <a:latin typeface="Be Vietnam Pro" pitchFamily="34" charset="0"/>
-                <a:ea typeface="Be Vietnam Pro" pitchFamily="34" charset="-122"/>
-                <a:cs typeface="Be Vietnam Pro" pitchFamily="34" charset="-120"/>
-              </a:rPr>
-              <a:t> thiết</a:t>
-            </a:r>
-            <a:r>
-              <a:rPr lang="en-US" sz="1950" dirty="0" spc="-32" kern="0">
-                <a:solidFill>
-                  <a:srgbClr val="C4C8D6"/>
-                </a:solidFill>
-                <a:latin typeface="Be Vietnam Pro" pitchFamily="34" charset="0"/>
-                <a:ea typeface="Be Vietnam Pro" pitchFamily="34" charset="-122"/>
-                <a:cs typeface="Be Vietnam Pro" pitchFamily="34" charset="-120"/>
-              </a:rPr>
-              <a:t> kế</a:t>
             </a:r>
             <a:endParaRPr lang="en-US" sz="1950" dirty="0"/>
           </a:p>
@@ -5158,10 +5092,10 @@
                 <a:ea typeface="Be Vietnam Pro" pitchFamily="34" charset="-122"/>
                 <a:cs typeface="Be Vietnam Pro" pitchFamily="34" charset="-120"/>
               </a:rPr>
-              <a:t> 2026-10-18.</a:t>
-            </a:r>
-            <a:r>
-              <a:rPr lang="en-US" sz="1950" dirty="0" spc="0" kern="0">
+              <a:t> 2026-10-19.</a:t>
+            </a:r>
+            <a:r>
+              <a:rPr lang="en-US" sz="1950" dirty="0" spc="1" kern="0">
                 <a:solidFill>
                   <a:srgbClr val="C4C8D6"/>
                 </a:solidFill>
@@ -5183,7 +5117,7 @@
               <a:t> minh</a:t>
             </a:r>
             <a:r>
-              <a:rPr lang="en-US" sz="1950" dirty="0" spc="-3" kern="0">
+              <a:rPr lang="en-US" sz="1950" dirty="0" spc="-4" kern="0">
                 <a:solidFill>
                   <a:srgbClr val="C4C8D6"/>
                 </a:solidFill>
@@ -7911,7 +7845,7 @@
               <a:buNone/>
             </a:pPr>
             <a:r>
-              <a:rPr lang="en-US" sz="3300" b="1" dirty="0" spc="-3" kern="0">
+              <a:rPr lang="en-US" sz="3300" b="1" dirty="0" spc="-19" kern="0">
                 <a:solidFill>
                   <a:srgbClr val="7C93FF"/>
                 </a:solidFill>
@@ -7919,10 +7853,10 @@
                 <a:ea typeface="Be Vietnam Pro" pitchFamily="34" charset="-122"/>
                 <a:cs typeface="Be Vietnam Pro" pitchFamily="34" charset="-120"/>
               </a:rPr>
-              <a:t>Hai</a:t>
-            </a:r>
-            <a:r>
-              <a:rPr lang="en-US" sz="3300" b="1" dirty="0" spc="-6" kern="0">
+              <a:t>Một</a:t>
+            </a:r>
+            <a:r>
+              <a:rPr lang="en-US" sz="3300" b="1" dirty="0" spc="-8" kern="0">
                 <a:solidFill>
                   <a:srgbClr val="7C93FF"/>
                 </a:solidFill>
@@ -7930,10 +7864,10 @@
                 <a:ea typeface="Be Vietnam Pro" pitchFamily="34" charset="-122"/>
                 <a:cs typeface="Be Vietnam Pro" pitchFamily="34" charset="-120"/>
               </a:rPr>
-              <a:t> loại luồng,</a:t>
-            </a:r>
-            <a:r>
-              <a:rPr lang="en-US" sz="3300" b="1" dirty="0" spc="-17" kern="0">
+              <a:t> bên</a:t>
+            </a:r>
+            <a:r>
+              <a:rPr lang="en-US" sz="3300" b="1" dirty="0" spc="-5" kern="0">
                 <a:solidFill>
                   <a:srgbClr val="7C93FF"/>
                 </a:solidFill>
@@ -7941,10 +7875,32 @@
                 <a:ea typeface="Be Vietnam Pro" pitchFamily="34" charset="-122"/>
                 <a:cs typeface="Be Vietnam Pro" pitchFamily="34" charset="-120"/>
               </a:rPr>
+              <a:t> tạo</a:t>
+            </a:r>
+            <a:r>
+              <a:rPr lang="en-US" sz="3300" b="1" dirty="0" spc="-2" kern="0">
+                <a:solidFill>
+                  <a:srgbClr val="7C93FF"/>
+                </a:solidFill>
+                <a:latin typeface="Be Vietnam Pro" pitchFamily="34" charset="0"/>
+                <a:ea typeface="Be Vietnam Pro" pitchFamily="34" charset="-122"/>
+                <a:cs typeface="Be Vietnam Pro" pitchFamily="34" charset="-120"/>
+              </a:rPr>
+              <a:t> việc,</a:t>
+            </a:r>
+            <a:r>
+              <a:rPr lang="en-US" sz="3300" b="1" dirty="0" spc="-18" kern="0">
+                <a:solidFill>
+                  <a:srgbClr val="7C93FF"/>
+                </a:solidFill>
+                <a:latin typeface="Be Vietnam Pro" pitchFamily="34" charset="0"/>
+                <a:ea typeface="Be Vietnam Pro" pitchFamily="34" charset="-122"/>
+                <a:cs typeface="Be Vietnam Pro" pitchFamily="34" charset="-120"/>
+              </a:rPr>
               <a:t> một</a:t>
             </a:r>
             <a:r>
-              <a:rPr lang="en-US" sz="3300" b="1" dirty="0" spc="-8" kern="0">
+              <a:rPr lang="en-US" sz="3300" b="1" dirty="0" spc="-9" kern="0">
                 <a:solidFill>
                   <a:srgbClr val="7C93FF"/>
                 </a:solidFill>
@@ -7952,10 +7908,10 @@
                 <a:ea typeface="Be Vietnam Pro" pitchFamily="34" charset="-122"/>
                 <a:cs typeface="Be Vietnam Pro" pitchFamily="34" charset="-120"/>
               </a:rPr>
-              <a:t> hàng</a:t>
-            </a:r>
-            <a:r>
-              <a:rPr lang="en-US" sz="3300" b="1" dirty="0" spc="11" kern="0">
+              <a:t> bên</a:t>
+            </a:r>
+            <a:r>
+              <a:rPr lang="en-US" sz="3300" b="1" dirty="0" spc="-4" kern="0">
                 <a:solidFill>
                   <a:srgbClr val="7C93FF"/>
                 </a:solidFill>
@@ -7963,7 +7919,7 @@
                 <a:ea typeface="Be Vietnam Pro" pitchFamily="34" charset="-122"/>
                 <a:cs typeface="Be Vietnam Pro" pitchFamily="34" charset="-120"/>
               </a:rPr>
-              <a:t> đợi</a:t>
+              <a:t> nhận</a:t>
             </a:r>
             <a:endParaRPr lang="en-US" sz="3300" dirty="0"/>
           </a:p>
@@ -7997,26 +7953,37 @@
               <a:buNone/>
             </a:pPr>
             <a:r>
-              <a:rPr lang="en-US" sz="2700" dirty="0" spc="-17" kern="0">
-                <a:solidFill>
-                  <a:srgbClr val="F3EEE3"/>
-                </a:solidFill>
-                <a:latin typeface="Be Vietnam Pro" pitchFamily="34" charset="0"/>
-                <a:ea typeface="Be Vietnam Pro" pitchFamily="34" charset="-122"/>
-                <a:cs typeface="Be Vietnam Pro" pitchFamily="34" charset="-120"/>
-              </a:rPr>
-              <a:t>Luồng</a:t>
-            </a:r>
-            <a:r>
-              <a:rPr lang="en-US" sz="2700" dirty="0" spc="-10" kern="0">
-                <a:solidFill>
-                  <a:srgbClr val="F3EEE3"/>
-                </a:solidFill>
-                <a:latin typeface="Be Vietnam Pro" pitchFamily="34" charset="0"/>
-                <a:ea typeface="Be Vietnam Pro" pitchFamily="34" charset="-122"/>
-                <a:cs typeface="Be Vietnam Pro" pitchFamily="34" charset="-120"/>
-              </a:rPr>
-              <a:t> sản xuất</a:t>
+              <a:rPr lang="en-US" sz="2700" dirty="0" spc="-1" kern="0">
+                <a:solidFill>
+                  <a:srgbClr val="F3EEE3"/>
+                </a:solidFill>
+                <a:latin typeface="Be Vietnam Pro" pitchFamily="34" charset="0"/>
+                <a:ea typeface="Be Vietnam Pro" pitchFamily="34" charset="-122"/>
+                <a:cs typeface="Be Vietnam Pro" pitchFamily="34" charset="-120"/>
+              </a:rPr>
+              <a:t>Hai</a:t>
+            </a:r>
+            <a:r>
+              <a:rPr lang="en-US" sz="2700" dirty="0" spc="-7" kern="0">
+                <a:solidFill>
+                  <a:srgbClr val="F3EEE3"/>
+                </a:solidFill>
+                <a:latin typeface="Be Vietnam Pro" pitchFamily="34" charset="0"/>
+                <a:ea typeface="Be Vietnam Pro" pitchFamily="34" charset="-122"/>
+                <a:cs typeface="Be Vietnam Pro" pitchFamily="34" charset="-120"/>
+              </a:rPr>
+              <a:t> bên</a:t>
+            </a:r>
+            <a:r>
+              <a:rPr lang="en-US" sz="2700" dirty="0" spc="-2" kern="0">
+                <a:solidFill>
+                  <a:srgbClr val="F3EEE3"/>
+                </a:solidFill>
+                <a:latin typeface="Be Vietnam Pro" pitchFamily="34" charset="0"/>
+                <a:ea typeface="Be Vietnam Pro" pitchFamily="34" charset="-122"/>
+                <a:cs typeface="Be Vietnam Pro" pitchFamily="34" charset="-120"/>
+              </a:rPr>
+              <a:t> nói</a:t>
             </a:r>
             <a:r>
               <a:rPr lang="en-US" sz="2700" dirty="0" spc="-14" kern="0">
@@ -8027,18 +7994,62 @@
                 <a:ea typeface="Be Vietnam Pro" pitchFamily="34" charset="-122"/>
                 <a:cs typeface="Be Vietnam Pro" pitchFamily="34" charset="-120"/>
               </a:rPr>
-              <a:t> tạo</a:t>
-            </a:r>
-            <a:r>
-              <a:rPr lang="en-US" sz="2700" dirty="0" spc="-4" kern="0">
-                <a:solidFill>
-                  <a:srgbClr val="F3EEE3"/>
-                </a:solidFill>
-                <a:latin typeface="Be Vietnam Pro" pitchFamily="34" charset="0"/>
-                <a:ea typeface="Be Vietnam Pro" pitchFamily="34" charset="-122"/>
-                <a:cs typeface="Be Vietnam Pro" pitchFamily="34" charset="-120"/>
-              </a:rPr>
-              <a:t> dữ</a:t>
+              <a:t> chuyện</a:t>
+            </a:r>
+            <a:r>
+              <a:rPr lang="en-US" sz="2700" dirty="0" spc="-2" kern="0">
+                <a:solidFill>
+                  <a:srgbClr val="F3EEE3"/>
+                </a:solidFill>
+                <a:latin typeface="Be Vietnam Pro" pitchFamily="34" charset="0"/>
+                <a:ea typeface="Be Vietnam Pro" pitchFamily="34" charset="-122"/>
+                <a:cs typeface="Be Vietnam Pro" pitchFamily="34" charset="-120"/>
+              </a:rPr>
+              <a:t> qua</a:t>
+            </a:r>
+            <a:r>
+              <a:rPr lang="en-US" sz="2700" dirty="0" spc="-8" kern="0">
+                <a:solidFill>
+                  <a:srgbClr val="F3EEE3"/>
+                </a:solidFill>
+                <a:latin typeface="Be Vietnam Pro" pitchFamily="34" charset="0"/>
+                <a:ea typeface="Be Vietnam Pro" pitchFamily="34" charset="-122"/>
+                <a:cs typeface="Be Vietnam Pro" pitchFamily="34" charset="-120"/>
+              </a:rPr>
+              <a:t> một</a:t>
+            </a:r>
+            <a:r>
+              <a:rPr lang="en-US" sz="2700" dirty="0" spc="-1" kern="0">
+                <a:solidFill>
+                  <a:srgbClr val="F3EEE3"/>
+                </a:solidFill>
+                <a:latin typeface="Be Vietnam Pro" pitchFamily="34" charset="0"/>
+                <a:ea typeface="Be Vietnam Pro" pitchFamily="34" charset="-122"/>
+                <a:cs typeface="Be Vietnam Pro" pitchFamily="34" charset="-120"/>
+              </a:rPr>
+              <a:t> hàng</a:t>
+            </a:r>
+            <a:r>
+              <a:rPr lang="en-US" sz="2700" dirty="0" spc="12" kern="0">
+                <a:solidFill>
+                  <a:srgbClr val="F3EEE3"/>
+                </a:solidFill>
+                <a:latin typeface="Be Vietnam Pro" pitchFamily="34" charset="0"/>
+                <a:ea typeface="Be Vietnam Pro" pitchFamily="34" charset="-122"/>
+                <a:cs typeface="Be Vietnam Pro" pitchFamily="34" charset="-120"/>
+              </a:rPr>
+              <a:t> đợi</a:t>
+            </a:r>
+            <a:r>
+              <a:rPr lang="en-US" sz="2700" dirty="0" spc="16" kern="0">
+                <a:solidFill>
+                  <a:srgbClr val="F3EEE3"/>
+                </a:solidFill>
+                <a:latin typeface="Be Vietnam Pro" pitchFamily="34" charset="0"/>
+                <a:ea typeface="Be Vietnam Pro" pitchFamily="34" charset="-122"/>
+                <a:cs typeface="Be Vietnam Pro" pitchFamily="34" charset="-120"/>
+              </a:rPr>
+              <a:t> đã</a:t>
             </a:r>
             <a:r>
               <a:rPr lang="en-US" sz="2700" dirty="0" spc="0" kern="0">
@@ -8049,84 +8060,29 @@
                 <a:ea typeface="Be Vietnam Pro" pitchFamily="34" charset="-122"/>
                 <a:cs typeface="Be Vietnam Pro" pitchFamily="34" charset="-120"/>
               </a:rPr>
-              <a:t> liệu,</a:t>
-            </a:r>
-            <a:r>
-              <a:rPr lang="en-US" sz="2700" dirty="0" spc="-1" kern="0">
-                <a:solidFill>
-                  <a:srgbClr val="F3EEE3"/>
-                </a:solidFill>
-                <a:latin typeface="Be Vietnam Pro" pitchFamily="34" charset="0"/>
-                <a:ea typeface="Be Vietnam Pro" pitchFamily="34" charset="-122"/>
-                <a:cs typeface="Be Vietnam Pro" pitchFamily="34" charset="-120"/>
-              </a:rPr>
-              <a:t> luồng</a:t>
-            </a:r>
-            <a:r>
-              <a:rPr lang="en-US" sz="2700" dirty="0" spc="0" kern="0">
-                <a:solidFill>
-                  <a:srgbClr val="F3EEE3"/>
-                </a:solidFill>
-                <a:latin typeface="Be Vietnam Pro" pitchFamily="34" charset="0"/>
-                <a:ea typeface="Be Vietnam Pro" pitchFamily="34" charset="-122"/>
-                <a:cs typeface="Be Vietnam Pro" pitchFamily="34" charset="-120"/>
-              </a:rPr>
-              <a:t> tiêu</a:t>
-            </a:r>
-            <a:r>
-              <a:rPr lang="en-US" sz="2700" dirty="0" spc="-1" kern="0">
-                <a:solidFill>
-                  <a:srgbClr val="F3EEE3"/>
-                </a:solidFill>
-                <a:latin typeface="Be Vietnam Pro" pitchFamily="34" charset="0"/>
-                <a:ea typeface="Be Vietnam Pro" pitchFamily="34" charset="-122"/>
-                <a:cs typeface="Be Vietnam Pro" pitchFamily="34" charset="-120"/>
-              </a:rPr>
-              <a:t> thụ</a:t>
-            </a:r>
-            <a:r>
-              <a:rPr lang="en-US" sz="2700" dirty="0" spc="-3" kern="0">
-                <a:solidFill>
-                  <a:srgbClr val="F3EEE3"/>
-                </a:solidFill>
-                <a:latin typeface="Be Vietnam Pro" pitchFamily="34" charset="0"/>
-                <a:ea typeface="Be Vietnam Pro" pitchFamily="34" charset="-122"/>
-                <a:cs typeface="Be Vietnam Pro" pitchFamily="34" charset="-120"/>
-              </a:rPr>
-              <a:t> xử</a:t>
-            </a:r>
-            <a:r>
-              <a:rPr lang="en-US" sz="2700" dirty="0" spc="-2" kern="0">
-                <a:solidFill>
-                  <a:srgbClr val="F3EEE3"/>
-                </a:solidFill>
-                <a:latin typeface="Be Vietnam Pro" pitchFamily="34" charset="0"/>
-                <a:ea typeface="Be Vietnam Pro" pitchFamily="34" charset="-122"/>
-                <a:cs typeface="Be Vietnam Pro" pitchFamily="34" charset="-120"/>
-              </a:rPr>
-              <a:t> lý</a:t>
-            </a:r>
-            <a:r>
-              <a:rPr lang="en-US" sz="2700" dirty="0" spc="-3" kern="0">
-                <a:solidFill>
-                  <a:srgbClr val="F3EEE3"/>
-                </a:solidFill>
-                <a:latin typeface="Be Vietnam Pro" pitchFamily="34" charset="0"/>
-                <a:ea typeface="Be Vietnam Pro" pitchFamily="34" charset="-122"/>
-                <a:cs typeface="Be Vietnam Pro" pitchFamily="34" charset="-120"/>
-              </a:rPr>
-              <a:t> dữ</a:t>
-            </a:r>
-            <a:r>
-              <a:rPr lang="en-US" sz="2700" dirty="0" spc="-1" kern="0">
-                <a:solidFill>
-                  <a:srgbClr val="F3EEE3"/>
-                </a:solidFill>
-                <a:latin typeface="Be Vietnam Pro" pitchFamily="34" charset="0"/>
-                <a:ea typeface="Be Vietnam Pro" pitchFamily="34" charset="-122"/>
-                <a:cs typeface="Be Vietnam Pro" pitchFamily="34" charset="-120"/>
-              </a:rPr>
-              <a:t> liệu.</a:t>
+              <a:t> có</a:t>
+            </a:r>
+            <a:r>
+              <a:rPr lang="en-US" sz="2700" dirty="0" spc="-5" kern="0">
+                <a:solidFill>
+                  <a:srgbClr val="F3EEE3"/>
+                </a:solidFill>
+                <a:latin typeface="Be Vietnam Pro" pitchFamily="34" charset="0"/>
+                <a:ea typeface="Be Vietnam Pro" pitchFamily="34" charset="-122"/>
+                <a:cs typeface="Be Vietnam Pro" pitchFamily="34" charset="-120"/>
+              </a:rPr>
+              <a:t> khóa</a:t>
+            </a:r>
+            <a:r>
+              <a:rPr lang="en-US" sz="2700" dirty="0" spc="-8" kern="0">
+                <a:solidFill>
+                  <a:srgbClr val="F3EEE3"/>
+                </a:solidFill>
+                <a:latin typeface="Be Vietnam Pro" pitchFamily="34" charset="0"/>
+                <a:ea typeface="Be Vietnam Pro" pitchFamily="34" charset="-122"/>
+                <a:cs typeface="Be Vietnam Pro" pitchFamily="34" charset="-120"/>
+              </a:rPr>
+              <a:t> sẵn.</a:t>
             </a:r>
             <a:endParaRPr lang="en-US" sz="2700" dirty="0"/>
           </a:p>
@@ -8234,18 +8190,7 @@
                 <a:ea typeface="Be Vietnam Pro" pitchFamily="34" charset="-122"/>
                 <a:cs typeface="Be Vietnam Pro" pitchFamily="34" charset="-120"/>
               </a:rPr>
-              <a:t>1</a:t>
-            </a:r>
-            <a:r>
-              <a:rPr lang="en-US" sz="2250" b="1" dirty="0" spc="-3" kern="0">
-                <a:solidFill>
-                  <a:srgbClr val="14161C"/>
-                </a:solidFill>
-                <a:latin typeface="Be Vietnam Pro" pitchFamily="34" charset="0"/>
-                <a:ea typeface="Be Vietnam Pro" pitchFamily="34" charset="-122"/>
-                <a:cs typeface="Be Vietnam Pro" pitchFamily="34" charset="-120"/>
-              </a:rPr>
-              <a:t> hàng</a:t>
+              <a:t>hàng</a:t>
             </a:r>
             <a:r>
               <a:rPr lang="en-US" sz="2250" b="1" dirty="0" spc="13" kern="0">
@@ -8259,15 +8204,26 @@
               <a:t> đợi</a:t>
             </a:r>
             <a:r>
-              <a:rPr lang="en-US" sz="2250" b="1" dirty="0" spc="2" kern="0">
-                <a:solidFill>
-                  <a:srgbClr val="14161C"/>
-                </a:solidFill>
-                <a:latin typeface="Be Vietnam Pro" pitchFamily="34" charset="0"/>
-                <a:ea typeface="Be Vietnam Pro" pitchFamily="34" charset="-122"/>
-                <a:cs typeface="Be Vietnam Pro" pitchFamily="34" charset="-120"/>
-              </a:rPr>
-              <a:t> chặn</a:t>
+              <a:rPr lang="en-US" sz="2250" b="1" dirty="0" spc="1" kern="0">
+                <a:solidFill>
+                  <a:srgbClr val="14161C"/>
+                </a:solidFill>
+                <a:latin typeface="Be Vietnam Pro" pitchFamily="34" charset="0"/>
+                <a:ea typeface="Be Vietnam Pro" pitchFamily="34" charset="-122"/>
+                <a:cs typeface="Be Vietnam Pro" pitchFamily="34" charset="-120"/>
+              </a:rPr>
+              <a:t> có</a:t>
+            </a:r>
+            <a:r>
+              <a:rPr lang="en-US" sz="2250" b="1" dirty="0" spc="-1" kern="0">
+                <a:solidFill>
+                  <a:srgbClr val="14161C"/>
+                </a:solidFill>
+                <a:latin typeface="Be Vietnam Pro" pitchFamily="34" charset="0"/>
+                <a:ea typeface="Be Vietnam Pro" pitchFamily="34" charset="-122"/>
+                <a:cs typeface="Be Vietnam Pro" pitchFamily="34" charset="-120"/>
+              </a:rPr>
+              <a:t> khóa</a:t>
             </a:r>
             <a:endParaRPr lang="en-US" sz="2250" dirty="0"/>
           </a:p>
@@ -8373,6 +8329,39 @@
               <a:buNone/>
             </a:pPr>
             <a:r>
+              <a:rPr lang="en-US" sz="2700" dirty="0" spc="9" kern="0">
+                <a:solidFill>
+                  <a:srgbClr val="F3EEE3"/>
+                </a:solidFill>
+                <a:latin typeface="Be Vietnam Pro" pitchFamily="34" charset="0"/>
+                <a:ea typeface="Be Vietnam Pro" pitchFamily="34" charset="-122"/>
+                <a:cs typeface="Be Vietnam Pro" pitchFamily="34" charset="-120"/>
+              </a:rPr>
+              <a:t>Người</a:t>
+            </a:r>
+            <a:r>
+              <a:rPr lang="en-US" sz="2700" dirty="0" spc="-3" kern="0">
+                <a:solidFill>
+                  <a:srgbClr val="F3EEE3"/>
+                </a:solidFill>
+                <a:latin typeface="Be Vietnam Pro" pitchFamily="34" charset="0"/>
+                <a:ea typeface="Be Vietnam Pro" pitchFamily="34" charset="-122"/>
+                <a:cs typeface="Be Vietnam Pro" pitchFamily="34" charset="-120"/>
+              </a:rPr>
+              <a:t> dùng</a:t>
+            </a:r>
+            <a:r>
+              <a:rPr lang="en-US" sz="2700" dirty="0" spc="-2" kern="0">
+                <a:solidFill>
+                  <a:srgbClr val="F3EEE3"/>
+                </a:solidFill>
+                <a:latin typeface="Be Vietnam Pro" pitchFamily="34" charset="0"/>
+                <a:ea typeface="Be Vietnam Pro" pitchFamily="34" charset="-122"/>
+                <a:cs typeface="Be Vietnam Pro" pitchFamily="34" charset="-120"/>
+              </a:rPr>
+              <a:t> không phải</a:t>
+            </a:r>
+            <a:r>
               <a:rPr lang="en-US" sz="2700" dirty="0" spc="0" kern="0">
                 <a:solidFill>
                   <a:srgbClr val="F3EEE3"/>
@@ -8381,18 +8370,18 @@
                 <a:ea typeface="Be Vietnam Pro" pitchFamily="34" charset="-122"/>
                 <a:cs typeface="Be Vietnam Pro" pitchFamily="34" charset="-120"/>
               </a:rPr>
-              <a:t>Hàng</a:t>
-            </a:r>
-            <a:r>
-              <a:rPr lang="en-US" sz="2700" dirty="0" spc="12" kern="0">
-                <a:solidFill>
-                  <a:srgbClr val="F3EEE3"/>
-                </a:solidFill>
-                <a:latin typeface="Be Vietnam Pro" pitchFamily="34" charset="0"/>
-                <a:ea typeface="Be Vietnam Pro" pitchFamily="34" charset="-122"/>
-                <a:cs typeface="Be Vietnam Pro" pitchFamily="34" charset="-120"/>
-              </a:rPr>
-              <a:t> đợi</a:t>
+              <a:t> tự</a:t>
+            </a:r>
+            <a:r>
+              <a:rPr lang="en-US" sz="2700" dirty="0" spc="-5" kern="0">
+                <a:solidFill>
+                  <a:srgbClr val="F3EEE3"/>
+                </a:solidFill>
+                <a:latin typeface="Be Vietnam Pro" pitchFamily="34" charset="0"/>
+                <a:ea typeface="Be Vietnam Pro" pitchFamily="34" charset="-122"/>
+                <a:cs typeface="Be Vietnam Pro" pitchFamily="34" charset="-120"/>
+              </a:rPr>
+              <a:t> viết khóa</a:t>
             </a:r>
             <a:r>
               <a:rPr lang="en-US" sz="2700" dirty="0" spc="-1" kern="0">
@@ -8403,40 +8392,7 @@
                 <a:ea typeface="Be Vietnam Pro" pitchFamily="34" charset="-122"/>
                 <a:cs typeface="Be Vietnam Pro" pitchFamily="34" charset="-120"/>
               </a:rPr>
-              <a:t> chặn làm</a:t>
-            </a:r>
-            <a:r>
-              <a:rPr lang="en-US" sz="2700" dirty="0" spc="-7" kern="0">
-                <a:solidFill>
-                  <a:srgbClr val="F3EEE3"/>
-                </a:solidFill>
-                <a:latin typeface="Be Vietnam Pro" pitchFamily="34" charset="0"/>
-                <a:ea typeface="Be Vietnam Pro" pitchFamily="34" charset="-122"/>
-                <a:cs typeface="Be Vietnam Pro" pitchFamily="34" charset="-120"/>
-              </a:rPr>
-              <a:t> bộ</a:t>
-            </a:r>
-            <a:r>
-              <a:rPr lang="en-US" sz="2700" dirty="0" spc="11" kern="0">
-                <a:solidFill>
-                  <a:srgbClr val="F3EEE3"/>
-                </a:solidFill>
-                <a:latin typeface="Be Vietnam Pro" pitchFamily="34" charset="0"/>
-                <a:ea typeface="Be Vietnam Pro" pitchFamily="34" charset="-122"/>
-                <a:cs typeface="Be Vietnam Pro" pitchFamily="34" charset="-120"/>
-              </a:rPr>
-              <a:t> đệm</a:t>
-            </a:r>
-            <a:r>
-              <a:rPr lang="en-US" sz="2700" dirty="0" spc="5" kern="0">
-                <a:solidFill>
-                  <a:srgbClr val="F3EEE3"/>
-                </a:solidFill>
-                <a:latin typeface="Be Vietnam Pro" pitchFamily="34" charset="0"/>
-                <a:ea typeface="Be Vietnam Pro" pitchFamily="34" charset="-122"/>
-                <a:cs typeface="Be Vietnam Pro" pitchFamily="34" charset="-120"/>
-              </a:rPr>
-              <a:t> giữa</a:t>
+              <a:t> cho</a:t>
             </a:r>
             <a:r>
               <a:rPr lang="en-US" sz="2700" dirty="0" spc="-2" kern="0">
@@ -8447,18 +8403,18 @@
                 <a:ea typeface="Be Vietnam Pro" pitchFamily="34" charset="-122"/>
                 <a:cs typeface="Be Vietnam Pro" pitchFamily="34" charset="-120"/>
               </a:rPr>
-              <a:t> hai</a:t>
-            </a:r>
-            <a:r>
-              <a:rPr lang="en-US" sz="2700" dirty="0" spc="-6" kern="0">
-                <a:solidFill>
-                  <a:srgbClr val="F3EEE3"/>
-                </a:solidFill>
-                <a:latin typeface="Be Vietnam Pro" pitchFamily="34" charset="0"/>
-                <a:ea typeface="Be Vietnam Pro" pitchFamily="34" charset="-122"/>
-                <a:cs typeface="Be Vietnam Pro" pitchFamily="34" charset="-120"/>
-              </a:rPr>
-              <a:t> bên.</a:t>
+              <a:t> hàng</a:t>
+            </a:r>
+            <a:r>
+              <a:rPr lang="en-US" sz="2700" dirty="0" spc="9" kern="0">
+                <a:solidFill>
+                  <a:srgbClr val="F3EEE3"/>
+                </a:solidFill>
+                <a:latin typeface="Be Vietnam Pro" pitchFamily="34" charset="0"/>
+                <a:ea typeface="Be Vietnam Pro" pitchFamily="34" charset="-122"/>
+                <a:cs typeface="Be Vietnam Pro" pitchFamily="34" charset="-120"/>
+              </a:rPr>
+              <a:t> đợi.</a:t>
             </a:r>
             <a:endParaRPr lang="en-US" sz="2700" dirty="0"/>
           </a:p>
@@ -8834,7 +8790,7 @@
               <a:t> đợi</a:t>
             </a:r>
             <a:r>
-              <a:rPr lang="en-US" sz="2250" b="1" dirty="0" spc="2" kern="0">
+              <a:rPr lang="en-US" sz="2250" b="1" dirty="0" spc="0" kern="0">
                 <a:solidFill>
                   <a:srgbClr val="7C93FF"/>
                 </a:solidFill>
@@ -8842,7 +8798,7 @@
                 <a:ea typeface="Be Vietnam Pro" pitchFamily="34" charset="-122"/>
                 <a:cs typeface="Be Vietnam Pro" pitchFamily="34" charset="-120"/>
               </a:rPr>
-              <a:t> chặn</a:t>
+              <a:t> có</a:t>
             </a:r>
             <a:r>
               <a:rPr lang="en-US" sz="2250" b="1" dirty="0" spc="-1" kern="0">
@@ -8853,10 +8809,10 @@
                 <a:ea typeface="Be Vietnam Pro" pitchFamily="34" charset="-122"/>
                 <a:cs typeface="Be Vietnam Pro" pitchFamily="34" charset="-120"/>
               </a:rPr>
-              <a:t> (bộ</a:t>
-            </a:r>
-            <a:r>
-              <a:rPr lang="en-US" sz="2250" b="1" dirty="0" spc="2" kern="0">
+              <a:t> khóa</a:t>
+            </a:r>
+            <a:r>
+              <a:rPr lang="en-US" sz="2250" b="1" dirty="0" spc="0" kern="0">
                 <a:solidFill>
                   <a:srgbClr val="7C93FF"/>
                 </a:solidFill>
@@ -8864,7 +8820,7 @@
                 <a:ea typeface="Be Vietnam Pro" pitchFamily="34" charset="-122"/>
                 <a:cs typeface="Be Vietnam Pro" pitchFamily="34" charset="-120"/>
               </a:rPr>
-              <a:t> đệm)</a:t>
+              <a:t> sẵn</a:t>
             </a:r>
             <a:endParaRPr lang="en-US" sz="2250" dirty="0"/>
           </a:p>
@@ -9909,7 +9865,7 @@
               <a:t> luồng</a:t>
             </a:r>
             <a:r>
-              <a:rPr lang="en-US" sz="3300" b="1" dirty="0" spc="-6" kern="0">
+              <a:rPr lang="en-US" sz="3300" b="1" dirty="0" spc="-2" kern="0">
                 <a:solidFill>
                   <a:srgbClr val="1F3FD1"/>
                 </a:solidFill>
@@ -9917,10 +9873,10 @@
                 <a:ea typeface="Be Vietnam Pro" pitchFamily="34" charset="-122"/>
                 <a:cs typeface="Be Vietnam Pro" pitchFamily="34" charset="-120"/>
               </a:rPr>
-              <a:t> tái</a:t>
-            </a:r>
-            <a:r>
-              <a:rPr lang="en-US" sz="3300" b="1" dirty="0" spc="-4" kern="0">
+              <a:t> lập</a:t>
+            </a:r>
+            <a:r>
+              <a:rPr lang="en-US" sz="3300" b="1" dirty="0" spc="-3" kern="0">
                 <a:solidFill>
                   <a:srgbClr val="1F3FD1"/>
                 </a:solidFill>
@@ -9928,18 +9884,7 @@
                 <a:ea typeface="Be Vietnam Pro" pitchFamily="34" charset="-122"/>
                 <a:cs typeface="Be Vietnam Pro" pitchFamily="34" charset="-120"/>
               </a:rPr>
-              <a:t> sử</a:t>
-            </a:r>
-            <a:r>
-              <a:rPr lang="en-US" sz="3300" b="1" dirty="0" spc="-5" kern="0">
-                <a:solidFill>
-                  <a:srgbClr val="1F3FD1"/>
-                </a:solidFill>
-                <a:latin typeface="Be Vietnam Pro" pitchFamily="34" charset="0"/>
-                <a:ea typeface="Be Vietnam Pro" pitchFamily="34" charset="-122"/>
-                <a:cs typeface="Be Vietnam Pro" pitchFamily="34" charset="-120"/>
-              </a:rPr>
-              <a:t> dụng</a:t>
+              <a:t> sẵn</a:t>
             </a:r>
             <a:endParaRPr lang="en-US" sz="3300" dirty="0"/>
           </a:p>
@@ -9981,7 +9926,51 @@
                 <a:ea typeface="Be Vietnam Pro" pitchFamily="34" charset="-122"/>
                 <a:cs typeface="Be Vietnam Pro" pitchFamily="34" charset="-120"/>
               </a:rPr>
-              <a:t>Luồng</a:t>
+              <a:t>ThreadPoolExecutor</a:t>
+            </a:r>
+            <a:r>
+              <a:rPr lang="en-US" sz="2850" dirty="0" spc="-2" kern="0">
+                <a:solidFill>
+                  <a:srgbClr val="14161C"/>
+                </a:solidFill>
+                <a:latin typeface="Be Vietnam Pro" pitchFamily="34" charset="0"/>
+                <a:ea typeface="Be Vietnam Pro" pitchFamily="34" charset="-122"/>
+                <a:cs typeface="Be Vietnam Pro" pitchFamily="34" charset="-120"/>
+              </a:rPr>
+              <a:t> dùng</a:t>
+            </a:r>
+            <a:r>
+              <a:rPr lang="en-US" sz="2850" dirty="0" spc="-14" kern="0">
+                <a:solidFill>
+                  <a:srgbClr val="14161C"/>
+                </a:solidFill>
+                <a:latin typeface="Be Vietnam Pro" pitchFamily="34" charset="0"/>
+                <a:ea typeface="Be Vietnam Pro" pitchFamily="34" charset="-122"/>
+                <a:cs typeface="Be Vietnam Pro" pitchFamily="34" charset="-120"/>
+              </a:rPr>
+              <a:t> tối</a:t>
+            </a:r>
+            <a:r>
+              <a:rPr lang="en-US" sz="2850" dirty="0" spc="22" kern="0">
+                <a:solidFill>
+                  <a:srgbClr val="14161C"/>
+                </a:solidFill>
+                <a:latin typeface="Be Vietnam Pro" pitchFamily="34" charset="0"/>
+                <a:ea typeface="Be Vietnam Pro" pitchFamily="34" charset="-122"/>
+                <a:cs typeface="Be Vietnam Pro" pitchFamily="34" charset="-120"/>
+              </a:rPr>
+              <a:t> đa</a:t>
+            </a:r>
+            <a:r>
+              <a:rPr lang="en-US" sz="2850" dirty="0" spc="-14" kern="0">
+                <a:solidFill>
+                  <a:srgbClr val="14161C"/>
+                </a:solidFill>
+                <a:latin typeface="Be Vietnam Pro" pitchFamily="34" charset="0"/>
+                <a:ea typeface="Be Vietnam Pro" pitchFamily="34" charset="-122"/>
+                <a:cs typeface="Be Vietnam Pro" pitchFamily="34" charset="-120"/>
+              </a:rPr>
+              <a:t> max_workers</a:t>
             </a:r>
             <a:r>
               <a:rPr lang="en-US" sz="2850" dirty="0" spc="-1" kern="0">
@@ -9992,40 +9981,29 @@
                 <a:ea typeface="Be Vietnam Pro" pitchFamily="34" charset="-122"/>
                 <a:cs typeface="Be Vietnam Pro" pitchFamily="34" charset="-120"/>
               </a:rPr>
-              <a:t> có</a:t>
-            </a:r>
-            <a:r>
-              <a:rPr lang="en-US" sz="2850" dirty="0" spc="-8" kern="0">
-                <a:solidFill>
-                  <a:srgbClr val="14161C"/>
-                </a:solidFill>
-                <a:latin typeface="Be Vietnam Pro" pitchFamily="34" charset="0"/>
-                <a:ea typeface="Be Vietnam Pro" pitchFamily="34" charset="-122"/>
-                <a:cs typeface="Be Vietnam Pro" pitchFamily="34" charset="-120"/>
-              </a:rPr>
-              <a:t> sẵn chạy</a:t>
-            </a:r>
-            <a:r>
-              <a:rPr lang="en-US" sz="2850" dirty="0" spc="-16" kern="0">
-                <a:solidFill>
-                  <a:srgbClr val="14161C"/>
-                </a:solidFill>
-                <a:latin typeface="Be Vietnam Pro" pitchFamily="34" charset="0"/>
-                <a:ea typeface="Be Vietnam Pro" pitchFamily="34" charset="-122"/>
-                <a:cs typeface="Be Vietnam Pro" pitchFamily="34" charset="-120"/>
-              </a:rPr>
-              <a:t> tác</a:t>
-            </a:r>
-            <a:r>
-              <a:rPr lang="en-US" sz="2850" dirty="0" spc="2" kern="0">
-                <a:solidFill>
-                  <a:srgbClr val="14161C"/>
-                </a:solidFill>
-                <a:latin typeface="Be Vietnam Pro" pitchFamily="34" charset="0"/>
-                <a:ea typeface="Be Vietnam Pro" pitchFamily="34" charset="-122"/>
-                <a:cs typeface="Be Vietnam Pro" pitchFamily="34" charset="-120"/>
-              </a:rPr>
-              <a:t> vụ,</a:t>
+              <a:t> luồng</a:t>
+            </a:r>
+            <a:r>
+              <a:rPr lang="en-US" sz="2850" dirty="0" spc="20" kern="0">
+                <a:solidFill>
+                  <a:srgbClr val="14161C"/>
+                </a:solidFill>
+                <a:latin typeface="Be Vietnam Pro" pitchFamily="34" charset="0"/>
+                <a:ea typeface="Be Vietnam Pro" pitchFamily="34" charset="-122"/>
+                <a:cs typeface="Be Vietnam Pro" pitchFamily="34" charset="-120"/>
+              </a:rPr>
+              <a:t> để</a:t>
+            </a:r>
+            <a:r>
+              <a:rPr lang="en-US" sz="2850" dirty="0" spc="-9" kern="0">
+                <a:solidFill>
+                  <a:srgbClr val="14161C"/>
+                </a:solidFill>
+                <a:latin typeface="Be Vietnam Pro" pitchFamily="34" charset="0"/>
+                <a:ea typeface="Be Vietnam Pro" pitchFamily="34" charset="-122"/>
+                <a:cs typeface="Be Vietnam Pro" pitchFamily="34" charset="-120"/>
+              </a:rPr>
+              <a:t> chạy</a:t>
             </a:r>
             <a:r>
               <a:rPr lang="en-US" sz="2850" dirty="0" spc="0" kern="0">
@@ -10036,18 +10014,7 @@
                 <a:ea typeface="Be Vietnam Pro" pitchFamily="34" charset="-122"/>
                 <a:cs typeface="Be Vietnam Pro" pitchFamily="34" charset="-120"/>
               </a:rPr>
-              <a:t> khỏi</a:t>
-            </a:r>
-            <a:r>
-              <a:rPr lang="en-US" sz="2850" dirty="0" spc="-17" kern="0">
-                <a:solidFill>
-                  <a:srgbClr val="14161C"/>
-                </a:solidFill>
-                <a:latin typeface="Be Vietnam Pro" pitchFamily="34" charset="0"/>
-                <a:ea typeface="Be Vietnam Pro" pitchFamily="34" charset="-122"/>
-                <a:cs typeface="Be Vietnam Pro" pitchFamily="34" charset="-120"/>
-              </a:rPr>
-              <a:t> tốn</a:t>
+              <a:t> các</a:t>
             </a:r>
             <a:r>
               <a:rPr lang="en-US" sz="2850" dirty="0" spc="1" kern="0">
@@ -10058,51 +10025,18 @@
                 <a:ea typeface="Be Vietnam Pro" pitchFamily="34" charset="-122"/>
                 <a:cs typeface="Be Vietnam Pro" pitchFamily="34" charset="-120"/>
               </a:rPr>
-              <a:t> chi</a:t>
-            </a:r>
-            <a:r>
-              <a:rPr lang="en-US" sz="2850" dirty="0" spc="0" kern="0">
-                <a:solidFill>
-                  <a:srgbClr val="14161C"/>
-                </a:solidFill>
-                <a:latin typeface="Be Vietnam Pro" pitchFamily="34" charset="0"/>
-                <a:ea typeface="Be Vietnam Pro" pitchFamily="34" charset="-122"/>
-                <a:cs typeface="Be Vietnam Pro" pitchFamily="34" charset="-120"/>
-              </a:rPr>
-              <a:t> phí</a:t>
-            </a:r>
-            <a:r>
-              <a:rPr lang="en-US" sz="2850" dirty="0" spc="-13" kern="0">
-                <a:solidFill>
-                  <a:srgbClr val="14161C"/>
-                </a:solidFill>
-                <a:latin typeface="Be Vietnam Pro" pitchFamily="34" charset="0"/>
-                <a:ea typeface="Be Vietnam Pro" pitchFamily="34" charset="-122"/>
-                <a:cs typeface="Be Vietnam Pro" pitchFamily="34" charset="-120"/>
-              </a:rPr>
-              <a:t> tạo</a:t>
-            </a:r>
-            <a:r>
-              <a:rPr lang="en-US" sz="2850" dirty="0" spc="-17" kern="0">
-                <a:solidFill>
-                  <a:srgbClr val="14161C"/>
-                </a:solidFill>
-                <a:latin typeface="Be Vietnam Pro" pitchFamily="34" charset="0"/>
-                <a:ea typeface="Be Vietnam Pro" pitchFamily="34" charset="-122"/>
-                <a:cs typeface="Be Vietnam Pro" pitchFamily="34" charset="-120"/>
-              </a:rPr>
-              <a:t> và</a:t>
-            </a:r>
-            <a:r>
-              <a:rPr lang="en-US" sz="2850" dirty="0" spc="0" kern="0">
-                <a:solidFill>
-                  <a:srgbClr val="14161C"/>
-                </a:solidFill>
-                <a:latin typeface="Be Vietnam Pro" pitchFamily="34" charset="0"/>
-                <a:ea typeface="Be Vietnam Pro" pitchFamily="34" charset="-122"/>
-                <a:cs typeface="Be Vietnam Pro" pitchFamily="34" charset="-120"/>
-              </a:rPr>
-              <a:t> hủy luồng.</a:t>
+              <a:t> lời</a:t>
+            </a:r>
+            <a:r>
+              <a:rPr lang="en-US" sz="2850" dirty="0" spc="-11" kern="0">
+                <a:solidFill>
+                  <a:srgbClr val="14161C"/>
+                </a:solidFill>
+                <a:latin typeface="Be Vietnam Pro" pitchFamily="34" charset="0"/>
+                <a:ea typeface="Be Vietnam Pro" pitchFamily="34" charset="-122"/>
+                <a:cs typeface="Be Vietnam Pro" pitchFamily="34" charset="-120"/>
+              </a:rPr>
+              <a:t> gọi.</a:t>
             </a:r>
             <a:endParaRPr lang="en-US" sz="2850" dirty="0"/>
           </a:p>
@@ -10137,6 +10071,39 @@
               <a:buNone/>
             </a:pPr>
             <a:r>
+              <a:rPr lang="en-US" sz="2250" b="1" dirty="0" spc="-7" kern="0">
+                <a:solidFill>
+                  <a:srgbClr val="F3EEE3"/>
+                </a:solidFill>
+                <a:latin typeface="Be Vietnam Pro" pitchFamily="34" charset="0"/>
+                <a:ea typeface="Be Vietnam Pro" pitchFamily="34" charset="-122"/>
+                <a:cs typeface="Be Vietnam Pro" pitchFamily="34" charset="-120"/>
+              </a:rPr>
+              <a:t>chồng</a:t>
+            </a:r>
+            <a:r>
+              <a:rPr lang="en-US" sz="2250" b="1" dirty="0" spc="5" kern="0">
+                <a:solidFill>
+                  <a:srgbClr val="F3EEE3"/>
+                </a:solidFill>
+                <a:latin typeface="Be Vietnam Pro" pitchFamily="34" charset="0"/>
+                <a:ea typeface="Be Vietnam Pro" pitchFamily="34" charset="-122"/>
+                <a:cs typeface="Be Vietnam Pro" pitchFamily="34" charset="-120"/>
+              </a:rPr>
+              <a:t> thời</a:t>
+            </a:r>
+            <a:r>
+              <a:rPr lang="en-US" sz="2250" b="1" dirty="0" spc="2" kern="0">
+                <a:solidFill>
+                  <a:srgbClr val="F3EEE3"/>
+                </a:solidFill>
+                <a:latin typeface="Be Vietnam Pro" pitchFamily="34" charset="0"/>
+                <a:ea typeface="Be Vietnam Pro" pitchFamily="34" charset="-122"/>
+                <a:cs typeface="Be Vietnam Pro" pitchFamily="34" charset="-120"/>
+              </a:rPr>
+              <a:t> gian</a:t>
+            </a:r>
+            <a:r>
               <a:rPr lang="en-US" sz="2250" b="1" dirty="0" spc="1" kern="0">
                 <a:solidFill>
                   <a:srgbClr val="F3EEE3"/>
@@ -10145,29 +10112,7 @@
                 <a:ea typeface="Be Vietnam Pro" pitchFamily="34" charset="-122"/>
                 <a:cs typeface="Be Vietnam Pro" pitchFamily="34" charset="-120"/>
               </a:rPr>
-              <a:t>nhiều tác</a:t>
-            </a:r>
-            <a:r>
-              <a:rPr lang="en-US" sz="2250" b="1" dirty="0" spc="3" kern="0">
-                <a:solidFill>
-                  <a:srgbClr val="F3EEE3"/>
-                </a:solidFill>
-                <a:latin typeface="Be Vietnam Pro" pitchFamily="34" charset="0"/>
-                <a:ea typeface="Be Vietnam Pro" pitchFamily="34" charset="-122"/>
-                <a:cs typeface="Be Vietnam Pro" pitchFamily="34" charset="-120"/>
-              </a:rPr>
-              <a:t> vụ</a:t>
-            </a:r>
-            <a:r>
-              <a:rPr lang="en-US" sz="2250" b="1" dirty="0" spc="-6" kern="0">
-                <a:solidFill>
-                  <a:srgbClr val="F3EEE3"/>
-                </a:solidFill>
-                <a:latin typeface="Be Vietnam Pro" pitchFamily="34" charset="0"/>
-                <a:ea typeface="Be Vietnam Pro" pitchFamily="34" charset="-122"/>
-                <a:cs typeface="Be Vietnam Pro" pitchFamily="34" charset="-120"/>
-              </a:rPr>
-              <a:t> ngắn</a:t>
+              <a:t> chờ</a:t>
             </a:r>
             <a:endParaRPr lang="en-US" sz="2250" dirty="0"/>
           </a:p>
@@ -10281,18 +10226,18 @@
                 <a:ea typeface="Be Vietnam Pro" pitchFamily="34" charset="-122"/>
                 <a:cs typeface="Be Vietnam Pro" pitchFamily="34" charset="-120"/>
               </a:rPr>
-              <a:t>Dùng lại luồng</a:t>
-            </a:r>
-            <a:r>
-              <a:rPr lang="en-US" sz="2700" dirty="0" spc="-9" kern="0">
-                <a:solidFill>
-                  <a:srgbClr val="14161C"/>
-                </a:solidFill>
-                <a:latin typeface="Be Vietnam Pro" pitchFamily="34" charset="0"/>
-                <a:ea typeface="Be Vietnam Pro" pitchFamily="34" charset="-122"/>
-                <a:cs typeface="Be Vietnam Pro" pitchFamily="34" charset="-120"/>
-              </a:rPr>
-              <a:t> thay</a:t>
+              <a:t>Hợp</a:t>
+            </a:r>
+            <a:r>
+              <a:rPr lang="en-US" sz="2700" dirty="0" spc="-2" kern="0">
+                <a:solidFill>
+                  <a:srgbClr val="14161C"/>
+                </a:solidFill>
+                <a:latin typeface="Be Vietnam Pro" pitchFamily="34" charset="0"/>
+                <a:ea typeface="Be Vietnam Pro" pitchFamily="34" charset="-122"/>
+                <a:cs typeface="Be Vietnam Pro" pitchFamily="34" charset="-120"/>
+              </a:rPr>
+              <a:t> việc</a:t>
             </a:r>
             <a:r>
               <a:rPr lang="en-US" sz="2700" dirty="0" spc="-1" kern="0">
@@ -10303,29 +10248,18 @@
                 <a:ea typeface="Be Vietnam Pro" pitchFamily="34" charset="-122"/>
                 <a:cs typeface="Be Vietnam Pro" pitchFamily="34" charset="-120"/>
               </a:rPr>
-              <a:t> vì</a:t>
-            </a:r>
-            <a:r>
-              <a:rPr lang="en-US" sz="2700" dirty="0" spc="-14" kern="0">
-                <a:solidFill>
-                  <a:srgbClr val="14161C"/>
-                </a:solidFill>
-                <a:latin typeface="Be Vietnam Pro" pitchFamily="34" charset="0"/>
-                <a:ea typeface="Be Vietnam Pro" pitchFamily="34" charset="-122"/>
-                <a:cs typeface="Be Vietnam Pro" pitchFamily="34" charset="-120"/>
-              </a:rPr>
-              <a:t> tạo</a:t>
-            </a:r>
-            <a:r>
-              <a:rPr lang="en-US" sz="2700" dirty="0" spc="-29" kern="0">
-                <a:solidFill>
-                  <a:srgbClr val="14161C"/>
-                </a:solidFill>
-                <a:latin typeface="Be Vietnam Pro" pitchFamily="34" charset="0"/>
-                <a:ea typeface="Be Vietnam Pro" pitchFamily="34" charset="-122"/>
-                <a:cs typeface="Be Vietnam Pro" pitchFamily="34" charset="-120"/>
-              </a:rPr>
-              <a:t> rồi</a:t>
+              <a:t> có</a:t>
+            </a:r>
+            <a:r>
+              <a:rPr lang="en-US" sz="2700" dirty="0" spc="0" kern="0">
+                <a:solidFill>
+                  <a:srgbClr val="14161C"/>
+                </a:solidFill>
+                <a:latin typeface="Be Vietnam Pro" pitchFamily="34" charset="0"/>
+                <a:ea typeface="Be Vietnam Pro" pitchFamily="34" charset="-122"/>
+                <a:cs typeface="Be Vietnam Pro" pitchFamily="34" charset="-120"/>
+              </a:rPr>
+              <a:t> thời</a:t>
             </a:r>
             <a:r>
               <a:rPr lang="en-US" sz="2700" dirty="0" spc="-3" kern="0">
@@ -10336,7 +10270,73 @@
                 <a:ea typeface="Be Vietnam Pro" pitchFamily="34" charset="-122"/>
                 <a:cs typeface="Be Vietnam Pro" pitchFamily="34" charset="-120"/>
               </a:rPr>
-              <a:t> hủy.</a:t>
+              <a:t> gian</a:t>
+            </a:r>
+            <a:r>
+              <a:rPr lang="en-US" sz="2700" dirty="0" spc="1" kern="0">
+                <a:solidFill>
+                  <a:srgbClr val="14161C"/>
+                </a:solidFill>
+                <a:latin typeface="Be Vietnam Pro" pitchFamily="34" charset="0"/>
+                <a:ea typeface="Be Vietnam Pro" pitchFamily="34" charset="-122"/>
+                <a:cs typeface="Be Vietnam Pro" pitchFamily="34" charset="-120"/>
+              </a:rPr>
+              <a:t> chờ;</a:t>
+            </a:r>
+            <a:r>
+              <a:rPr lang="en-US" sz="2700" dirty="0" spc="-2" kern="0">
+                <a:solidFill>
+                  <a:srgbClr val="14161C"/>
+                </a:solidFill>
+                <a:latin typeface="Be Vietnam Pro" pitchFamily="34" charset="0"/>
+                <a:ea typeface="Be Vietnam Pro" pitchFamily="34" charset="-122"/>
+                <a:cs typeface="Be Vietnam Pro" pitchFamily="34" charset="-120"/>
+              </a:rPr>
+              <a:t> không hợp</a:t>
+            </a:r>
+            <a:r>
+              <a:rPr lang="en-US" sz="2700" dirty="0" spc="-3" kern="0">
+                <a:solidFill>
+                  <a:srgbClr val="14161C"/>
+                </a:solidFill>
+                <a:latin typeface="Be Vietnam Pro" pitchFamily="34" charset="0"/>
+                <a:ea typeface="Be Vietnam Pro" pitchFamily="34" charset="-122"/>
+                <a:cs typeface="Be Vietnam Pro" pitchFamily="34" charset="-120"/>
+              </a:rPr>
+              <a:t> việc</a:t>
+            </a:r>
+            <a:r>
+              <a:rPr lang="en-US" sz="2700" dirty="0" spc="-8" kern="0">
+                <a:solidFill>
+                  <a:srgbClr val="14161C"/>
+                </a:solidFill>
+                <a:latin typeface="Be Vietnam Pro" pitchFamily="34" charset="0"/>
+                <a:ea typeface="Be Vietnam Pro" pitchFamily="34" charset="-122"/>
+                <a:cs typeface="Be Vietnam Pro" pitchFamily="34" charset="-120"/>
+              </a:rPr>
+              <a:t> chạy</a:t>
+            </a:r>
+            <a:r>
+              <a:rPr lang="en-US" sz="2700" dirty="0" spc="-41" kern="0">
+                <a:solidFill>
+                  <a:srgbClr val="14161C"/>
+                </a:solidFill>
+                <a:latin typeface="Be Vietnam Pro" pitchFamily="34" charset="0"/>
+                <a:ea typeface="Be Vietnam Pro" pitchFamily="34" charset="-122"/>
+                <a:cs typeface="Be Vietnam Pro" pitchFamily="34" charset="-120"/>
+              </a:rPr>
+              <a:t> rất</a:t>
+            </a:r>
+            <a:r>
+              <a:rPr lang="en-US" sz="2700" dirty="0" spc="0" kern="0">
+                <a:solidFill>
+                  <a:srgbClr val="14161C"/>
+                </a:solidFill>
+                <a:latin typeface="Be Vietnam Pro" pitchFamily="34" charset="0"/>
+                <a:ea typeface="Be Vietnam Pro" pitchFamily="34" charset="-122"/>
+                <a:cs typeface="Be Vietnam Pro" pitchFamily="34" charset="-120"/>
+              </a:rPr>
+              <a:t> lâu.</a:t>
             </a:r>
             <a:endParaRPr lang="en-US" sz="2700" dirty="0"/>
           </a:p>
@@ -11731,7 +11731,7 @@
               <a:buNone/>
             </a:pPr>
             <a:r>
-              <a:rPr lang="en-US" sz="3300" b="1" dirty="0" spc="-19" kern="0">
+              <a:rPr lang="en-US" sz="3300" b="1" dirty="0" spc="-5" kern="0">
                 <a:solidFill>
                   <a:srgbClr val="7C93FF"/>
                 </a:solidFill>
@@ -11739,10 +11739,10 @@
                 <a:ea typeface="Be Vietnam Pro" pitchFamily="34" charset="-122"/>
                 <a:cs typeface="Be Vietnam Pro" pitchFamily="34" charset="-120"/>
               </a:rPr>
-              <a:t>Một</a:t>
-            </a:r>
-            <a:r>
-              <a:rPr lang="en-US" sz="3300" b="1" dirty="0" spc="-8" kern="0">
+              <a:t>Nhận</a:t>
+            </a:r>
+            <a:r>
+              <a:rPr lang="en-US" sz="3300" b="1" dirty="0" spc="-16" kern="0">
                 <a:solidFill>
                   <a:srgbClr val="7C93FF"/>
                 </a:solidFill>
@@ -11750,10 +11750,10 @@
                 <a:ea typeface="Be Vietnam Pro" pitchFamily="34" charset="-122"/>
                 <a:cs typeface="Be Vietnam Pro" pitchFamily="34" charset="-120"/>
               </a:rPr>
-              <a:t> bên</a:t>
-            </a:r>
-            <a:r>
-              <a:rPr lang="en-US" sz="3300" b="1" dirty="0" spc="-1" kern="0">
+              <a:t> ngay,</a:t>
+            </a:r>
+            <a:r>
+              <a:rPr lang="en-US" sz="3300" b="1" dirty="0" spc="-17" kern="0">
                 <a:solidFill>
                   <a:srgbClr val="7C93FF"/>
                 </a:solidFill>
@@ -11761,10 +11761,10 @@
                 <a:ea typeface="Be Vietnam Pro" pitchFamily="34" charset="-122"/>
                 <a:cs typeface="Be Vietnam Pro" pitchFamily="34" charset="-120"/>
               </a:rPr>
-              <a:t> giữ,</a:t>
-            </a:r>
-            <a:r>
-              <a:rPr lang="en-US" sz="3300" b="1" dirty="0" spc="-17" kern="0">
+              <a:t> lấy</a:t>
+            </a:r>
+            <a:r>
+              <a:rPr lang="en-US" sz="3300" b="1" dirty="0" spc="-41" kern="0">
                 <a:solidFill>
                   <a:srgbClr val="7C93FF"/>
                 </a:solidFill>
@@ -11772,10 +11772,10 @@
                 <a:ea typeface="Be Vietnam Pro" pitchFamily="34" charset="-122"/>
                 <a:cs typeface="Be Vietnam Pro" pitchFamily="34" charset="-120"/>
               </a:rPr>
-              <a:t> một</a:t>
-            </a:r>
-            <a:r>
-              <a:rPr lang="en-US" sz="3300" b="1" dirty="0" spc="-9" kern="0">
+              <a:t> kết</a:t>
+            </a:r>
+            <a:r>
+              <a:rPr lang="en-US" sz="3300" b="1" dirty="0" spc="1" kern="0">
                 <a:solidFill>
                   <a:srgbClr val="7C93FF"/>
                 </a:solidFill>
@@ -11783,10 +11783,10 @@
                 <a:ea typeface="Be Vietnam Pro" pitchFamily="34" charset="-122"/>
                 <a:cs typeface="Be Vietnam Pro" pitchFamily="34" charset="-120"/>
               </a:rPr>
-              <a:t> bên</a:t>
-            </a:r>
-            <a:r>
-              <a:rPr lang="en-US" sz="3300" b="1" dirty="0" spc="-17" kern="0">
+              <a:t> quả</a:t>
+            </a:r>
+            <a:r>
+              <a:rPr lang="en-US" sz="3300" b="1" dirty="0" spc="0" kern="0">
                 <a:solidFill>
                   <a:srgbClr val="7C93FF"/>
                 </a:solidFill>
@@ -11794,7 +11794,7 @@
                 <a:ea typeface="Be Vietnam Pro" pitchFamily="34" charset="-122"/>
                 <a:cs typeface="Be Vietnam Pro" pitchFamily="34" charset="-120"/>
               </a:rPr>
-              <a:t> lấy</a:t>
+              <a:t> sau</a:t>
             </a:r>
             <a:endParaRPr lang="en-US" sz="3300" dirty="0"/>
           </a:p>
@@ -11828,6 +11828,39 @@
               <a:buNone/>
             </a:pPr>
             <a:r>
+              <a:rPr lang="en-US" sz="2700" dirty="0" spc="-10" kern="0">
+                <a:solidFill>
+                  <a:srgbClr val="F3EEE3"/>
+                </a:solidFill>
+                <a:latin typeface="Be Vietnam Pro" pitchFamily="34" charset="0"/>
+                <a:ea typeface="Be Vietnam Pro" pitchFamily="34" charset="-122"/>
+                <a:cs typeface="Be Vietnam Pro" pitchFamily="34" charset="-120"/>
+              </a:rPr>
+              <a:t>Executor.submit</a:t>
+            </a:r>
+            <a:r>
+              <a:rPr lang="en-US" sz="2700" dirty="0" spc="-26" kern="0">
+                <a:solidFill>
+                  <a:srgbClr val="F3EEE3"/>
+                </a:solidFill>
+                <a:latin typeface="Be Vietnam Pro" pitchFamily="34" charset="0"/>
+                <a:ea typeface="Be Vietnam Pro" pitchFamily="34" charset="-122"/>
+                <a:cs typeface="Be Vietnam Pro" pitchFamily="34" charset="-120"/>
+              </a:rPr>
+              <a:t> trả</a:t>
+            </a:r>
+            <a:r>
+              <a:rPr lang="en-US" sz="2700" dirty="0" spc="-19" kern="0">
+                <a:solidFill>
+                  <a:srgbClr val="F3EEE3"/>
+                </a:solidFill>
+                <a:latin typeface="Be Vietnam Pro" pitchFamily="34" charset="0"/>
+                <a:ea typeface="Be Vietnam Pro" pitchFamily="34" charset="-122"/>
+                <a:cs typeface="Be Vietnam Pro" pitchFamily="34" charset="-120"/>
+              </a:rPr>
+              <a:t> về</a:t>
+            </a:r>
+            <a:r>
               <a:rPr lang="en-US" sz="2700" dirty="0" spc="-7" kern="0">
                 <a:solidFill>
                   <a:srgbClr val="F3EEE3"/>
@@ -11836,32 +11869,43 @@
                 <a:ea typeface="Be Vietnam Pro" pitchFamily="34" charset="-122"/>
                 <a:cs typeface="Be Vietnam Pro" pitchFamily="34" charset="-120"/>
               </a:rPr>
-              <a:t>Một</a:t>
-            </a:r>
-            <a:r>
-              <a:rPr lang="en-US" sz="2700" dirty="0" spc="-2" kern="0">
-                <a:solidFill>
-                  <a:srgbClr val="F3EEE3"/>
-                </a:solidFill>
-                <a:latin typeface="Be Vietnam Pro" pitchFamily="34" charset="0"/>
-                <a:ea typeface="Be Vietnam Pro" pitchFamily="34" charset="-122"/>
-                <a:cs typeface="Be Vietnam Pro" pitchFamily="34" charset="-120"/>
-              </a:rPr>
-              <a:t> việc dài</a:t>
-            </a:r>
-            <a:r>
-              <a:rPr lang="en-US" sz="2700" dirty="0" spc="-8" kern="0">
-                <a:solidFill>
-                  <a:srgbClr val="F3EEE3"/>
-                </a:solidFill>
-                <a:latin typeface="Be Vietnam Pro" pitchFamily="34" charset="0"/>
-                <a:ea typeface="Be Vietnam Pro" pitchFamily="34" charset="-122"/>
-                <a:cs typeface="Be Vietnam Pro" pitchFamily="34" charset="-120"/>
-              </a:rPr>
-              <a:t> chạy</a:t>
-            </a:r>
-            <a:r>
-              <a:rPr lang="en-US" sz="2700" dirty="0" spc="9" kern="0">
+              <a:t> một</a:t>
+            </a:r>
+            <a:r>
+              <a:rPr lang="en-US" sz="2700" dirty="0" spc="-15" kern="0">
+                <a:solidFill>
+                  <a:srgbClr val="F3EEE3"/>
+                </a:solidFill>
+                <a:latin typeface="Be Vietnam Pro" pitchFamily="34" charset="0"/>
+                <a:ea typeface="Be Vietnam Pro" pitchFamily="34" charset="-122"/>
+                <a:cs typeface="Be Vietnam Pro" pitchFamily="34" charset="-120"/>
+              </a:rPr>
+              <a:t> Future gói</a:t>
+            </a:r>
+            <a:r>
+              <a:rPr lang="en-US" sz="2700" dirty="0" spc="-1" kern="0">
+                <a:solidFill>
+                  <a:srgbClr val="F3EEE3"/>
+                </a:solidFill>
+                <a:latin typeface="Be Vietnam Pro" pitchFamily="34" charset="0"/>
+                <a:ea typeface="Be Vietnam Pro" pitchFamily="34" charset="-122"/>
+                <a:cs typeface="Be Vietnam Pro" pitchFamily="34" charset="-120"/>
+              </a:rPr>
+              <a:t> lời</a:t>
+            </a:r>
+            <a:r>
+              <a:rPr lang="en-US" sz="2700" dirty="0" spc="-16" kern="0">
+                <a:solidFill>
+                  <a:srgbClr val="F3EEE3"/>
+                </a:solidFill>
+                <a:latin typeface="Be Vietnam Pro" pitchFamily="34" charset="0"/>
+                <a:ea typeface="Be Vietnam Pro" pitchFamily="34" charset="-122"/>
+                <a:cs typeface="Be Vietnam Pro" pitchFamily="34" charset="-120"/>
+              </a:rPr>
+              <a:t> gọi bất</a:t>
+            </a:r>
+            <a:r>
+              <a:rPr lang="en-US" sz="2700" dirty="0" spc="8" kern="0">
                 <a:solidFill>
                   <a:srgbClr val="F3EEE3"/>
                 </a:solidFill>
@@ -11872,70 +11916,15 @@
               <a:t> đồng</a:t>
             </a:r>
             <a:r>
-              <a:rPr lang="en-US" sz="2700" dirty="0" spc="1" kern="0">
-                <a:solidFill>
-                  <a:srgbClr val="F3EEE3"/>
-                </a:solidFill>
-                <a:latin typeface="Be Vietnam Pro" pitchFamily="34" charset="0"/>
-                <a:ea typeface="Be Vietnam Pro" pitchFamily="34" charset="-122"/>
-                <a:cs typeface="Be Vietnam Pro" pitchFamily="34" charset="-120"/>
-              </a:rPr>
-              <a:t> thời,</a:t>
-            </a:r>
-            <a:r>
-              <a:rPr lang="en-US" sz="2700" dirty="0" spc="-39" kern="0">
-                <a:solidFill>
-                  <a:srgbClr val="F3EEE3"/>
-                </a:solidFill>
-                <a:latin typeface="Be Vietnam Pro" pitchFamily="34" charset="0"/>
-                <a:ea typeface="Be Vietnam Pro" pitchFamily="34" charset="-122"/>
-                <a:cs typeface="Be Vietnam Pro" pitchFamily="34" charset="-120"/>
-              </a:rPr>
-              <a:t> kết</a:t>
-            </a:r>
-            <a:r>
-              <a:rPr lang="en-US" sz="2700" dirty="0" spc="-1" kern="0">
-                <a:solidFill>
-                  <a:srgbClr val="F3EEE3"/>
-                </a:solidFill>
-                <a:latin typeface="Be Vietnam Pro" pitchFamily="34" charset="0"/>
-                <a:ea typeface="Be Vietnam Pro" pitchFamily="34" charset="-122"/>
-                <a:cs typeface="Be Vietnam Pro" pitchFamily="34" charset="-120"/>
-              </a:rPr>
-              <a:t> quả</a:t>
-            </a:r>
-            <a:r>
-              <a:rPr lang="en-US" sz="2700" dirty="0" spc="-13" kern="0">
-                <a:solidFill>
-                  <a:srgbClr val="F3EEE3"/>
-                </a:solidFill>
-                <a:latin typeface="Be Vietnam Pro" pitchFamily="34" charset="0"/>
-                <a:ea typeface="Be Vietnam Pro" pitchFamily="34" charset="-122"/>
-                <a:cs typeface="Be Vietnam Pro" pitchFamily="34" charset="-120"/>
-              </a:rPr>
-              <a:t> sẽ</a:t>
-            </a:r>
-            <a:r>
-              <a:rPr lang="en-US" sz="2700" dirty="0" spc="0" kern="0">
-                <a:solidFill>
-                  <a:srgbClr val="F3EEE3"/>
-                </a:solidFill>
-                <a:latin typeface="Be Vietnam Pro" pitchFamily="34" charset="0"/>
-                <a:ea typeface="Be Vietnam Pro" pitchFamily="34" charset="-122"/>
-                <a:cs typeface="Be Vietnam Pro" pitchFamily="34" charset="-120"/>
-              </a:rPr>
-              <a:t> có</a:t>
-            </a:r>
-            <a:r>
-              <a:rPr lang="en-US" sz="2700" dirty="0" spc="-8" kern="0">
-                <a:solidFill>
-                  <a:srgbClr val="F3EEE3"/>
-                </a:solidFill>
-                <a:latin typeface="Be Vietnam Pro" pitchFamily="34" charset="0"/>
-                <a:ea typeface="Be Vietnam Pro" pitchFamily="34" charset="-122"/>
-                <a:cs typeface="Be Vietnam Pro" pitchFamily="34" charset="-120"/>
-              </a:rPr>
-              <a:t> sau.</a:t>
+              <a:rPr lang="en-US" sz="2700" dirty="0" spc="-6" kern="0">
+                <a:solidFill>
+                  <a:srgbClr val="F3EEE3"/>
+                </a:solidFill>
+                <a:latin typeface="Be Vietnam Pro" pitchFamily="34" charset="0"/>
+                <a:ea typeface="Be Vietnam Pro" pitchFamily="34" charset="-122"/>
+                <a:cs typeface="Be Vietnam Pro" pitchFamily="34" charset="-120"/>
+              </a:rPr>
+              <a:t> bộ.</a:t>
             </a:r>
             <a:endParaRPr lang="en-US" sz="2700" dirty="0"/>
           </a:p>
@@ -11978,32 +11967,43 @@
                 <a:ea typeface="Be Vietnam Pro" pitchFamily="34" charset="-122"/>
                 <a:cs typeface="Be Vietnam Pro" pitchFamily="34" charset="-120"/>
               </a:rPr>
-              <a:t>promise</a:t>
+              <a:t>Future</a:t>
+            </a:r>
+            <a:r>
+              <a:rPr lang="en-US" sz="2250" b="1" dirty="0" spc="9" kern="0">
+                <a:solidFill>
+                  <a:srgbClr val="14161C"/>
+                </a:solidFill>
+                <a:latin typeface="Be Vietnam Pro" pitchFamily="34" charset="0"/>
+                <a:ea typeface="Be Vietnam Pro" pitchFamily="34" charset="-122"/>
+                <a:cs typeface="Be Vietnam Pro" pitchFamily="34" charset="-120"/>
+              </a:rPr>
+              <a:t> đại</a:t>
+            </a:r>
+            <a:r>
+              <a:rPr lang="en-US" sz="2250" b="1" dirty="0" spc="-1" kern="0">
+                <a:solidFill>
+                  <a:srgbClr val="14161C"/>
+                </a:solidFill>
+                <a:latin typeface="Be Vietnam Pro" pitchFamily="34" charset="0"/>
+                <a:ea typeface="Be Vietnam Pro" pitchFamily="34" charset="-122"/>
+                <a:cs typeface="Be Vietnam Pro" pitchFamily="34" charset="-120"/>
+              </a:rPr>
+              <a:t> diện</a:t>
+            </a:r>
+            <a:r>
+              <a:rPr lang="en-US" sz="2250" b="1" dirty="0" spc="-26" kern="0">
+                <a:solidFill>
+                  <a:srgbClr val="14161C"/>
+                </a:solidFill>
+                <a:latin typeface="Be Vietnam Pro" pitchFamily="34" charset="0"/>
+                <a:ea typeface="Be Vietnam Pro" pitchFamily="34" charset="-122"/>
+                <a:cs typeface="Be Vietnam Pro" pitchFamily="34" charset="-120"/>
+              </a:rPr>
+              <a:t> kết</a:t>
             </a:r>
             <a:r>
               <a:rPr lang="en-US" sz="2250" b="1" dirty="0" spc="2" kern="0">
-                <a:solidFill>
-                  <a:srgbClr val="14161C"/>
-                </a:solidFill>
-                <a:latin typeface="Be Vietnam Pro" pitchFamily="34" charset="0"/>
-                <a:ea typeface="Be Vietnam Pro" pitchFamily="34" charset="-122"/>
-                <a:cs typeface="Be Vietnam Pro" pitchFamily="34" charset="-120"/>
-              </a:rPr>
-              <a:t> giữ</a:t>
-            </a:r>
-            <a:r>
-              <a:rPr lang="en-US" sz="2250" b="1" dirty="0" spc="-27" kern="0">
-                <a:solidFill>
-                  <a:srgbClr val="14161C"/>
-                </a:solidFill>
-                <a:latin typeface="Be Vietnam Pro" pitchFamily="34" charset="0"/>
-                <a:ea typeface="Be Vietnam Pro" pitchFamily="34" charset="-122"/>
-                <a:cs typeface="Be Vietnam Pro" pitchFamily="34" charset="-120"/>
-              </a:rPr>
-              <a:t> kết</a:t>
-            </a:r>
-            <a:r>
-              <a:rPr lang="en-US" sz="2250" b="1" dirty="0" spc="3" kern="0">
                 <a:solidFill>
                   <a:srgbClr val="14161C"/>
                 </a:solidFill>
@@ -12046,26 +12046,15 @@
               <a:buNone/>
             </a:pPr>
             <a:r>
-              <a:rPr lang="en-US" sz="2250" b="1" dirty="0" spc="-3" kern="0">
-                <a:solidFill>
-                  <a:srgbClr val="14161C"/>
-                </a:solidFill>
-                <a:latin typeface="Be Vietnam Pro" pitchFamily="34" charset="0"/>
-                <a:ea typeface="Be Vietnam Pro" pitchFamily="34" charset="-122"/>
-                <a:cs typeface="Be Vietnam Pro" pitchFamily="34" charset="-120"/>
-              </a:rPr>
-              <a:t>future</a:t>
-            </a:r>
-            <a:r>
-              <a:rPr lang="en-US" sz="2250" b="1" dirty="0" spc="-8" kern="0">
-                <a:solidFill>
-                  <a:srgbClr val="14161C"/>
-                </a:solidFill>
-                <a:latin typeface="Be Vietnam Pro" pitchFamily="34" charset="0"/>
-                <a:ea typeface="Be Vietnam Pro" pitchFamily="34" charset="-122"/>
-                <a:cs typeface="Be Vietnam Pro" pitchFamily="34" charset="-120"/>
-              </a:rPr>
-              <a:t> lấy</a:t>
+              <a:rPr lang="en-US" sz="2250" b="1" dirty="0" spc="0" kern="0">
+                <a:solidFill>
+                  <a:srgbClr val="14161C"/>
+                </a:solidFill>
+                <a:latin typeface="Be Vietnam Pro" pitchFamily="34" charset="0"/>
+                <a:ea typeface="Be Vietnam Pro" pitchFamily="34" charset="-122"/>
+                <a:cs typeface="Be Vietnam Pro" pitchFamily="34" charset="-120"/>
+              </a:rPr>
+              <a:t>hỏi</a:t>
             </a:r>
             <a:r>
               <a:rPr lang="en-US" sz="2250" b="1" dirty="0" spc="-26" kern="0">
@@ -12087,7 +12076,7 @@
                 <a:ea typeface="Be Vietnam Pro" pitchFamily="34" charset="-122"/>
                 <a:cs typeface="Be Vietnam Pro" pitchFamily="34" charset="-120"/>
               </a:rPr>
-              <a:t> quả</a:t>
+              <a:t> quả sau</a:t>
             </a:r>
             <a:endParaRPr lang="en-US" sz="2250" dirty="0"/>
           </a:p>
@@ -12193,6 +12182,17 @@
               <a:buNone/>
             </a:pPr>
             <a:r>
+              <a:rPr lang="en-US" sz="2700" dirty="0" spc="-20" kern="0">
+                <a:solidFill>
+                  <a:srgbClr val="F3EEE3"/>
+                </a:solidFill>
+                <a:latin typeface="Be Vietnam Pro" pitchFamily="34" charset="0"/>
+                <a:ea typeface="Be Vietnam Pro" pitchFamily="34" charset="-122"/>
+                <a:cs typeface="Be Vietnam Pro" pitchFamily="34" charset="-120"/>
+              </a:rPr>
+              <a:t>Promise</a:t>
+            </a:r>
+            <a:r>
               <a:rPr lang="en-US" sz="2700" dirty="0" spc="-1" kern="0">
                 <a:solidFill>
                   <a:srgbClr val="F3EEE3"/>
@@ -12201,29 +12201,95 @@
                 <a:ea typeface="Be Vietnam Pro" pitchFamily="34" charset="-122"/>
                 <a:cs typeface="Be Vietnam Pro" pitchFamily="34" charset="-120"/>
               </a:rPr>
-              <a:t>Hợp</a:t>
-            </a:r>
-            <a:r>
-              <a:rPr lang="en-US" sz="2700" dirty="0" spc="-8" kern="0">
-                <a:solidFill>
-                  <a:srgbClr val="F3EEE3"/>
-                </a:solidFill>
-                <a:latin typeface="Be Vietnam Pro" pitchFamily="34" charset="0"/>
-                <a:ea typeface="Be Vietnam Pro" pitchFamily="34" charset="-122"/>
-                <a:cs typeface="Be Vietnam Pro" pitchFamily="34" charset="-120"/>
-              </a:rPr>
-              <a:t> chạy</a:t>
-            </a:r>
-            <a:r>
-              <a:rPr lang="en-US" sz="2700" dirty="0" spc="-3" kern="0">
-                <a:solidFill>
-                  <a:srgbClr val="F3EEE3"/>
-                </a:solidFill>
-                <a:latin typeface="Be Vietnam Pro" pitchFamily="34" charset="0"/>
-                <a:ea typeface="Be Vietnam Pro" pitchFamily="34" charset="-122"/>
-                <a:cs typeface="Be Vietnam Pro" pitchFamily="34" charset="-120"/>
-              </a:rPr>
-              <a:t> việc</a:t>
+              <a:t> là</a:t>
+            </a:r>
+            <a:r>
+              <a:rPr lang="en-US" sz="2700" dirty="0" spc="1" kern="0">
+                <a:solidFill>
+                  <a:srgbClr val="F3EEE3"/>
+                </a:solidFill>
+                <a:latin typeface="Be Vietnam Pro" pitchFamily="34" charset="0"/>
+                <a:ea typeface="Be Vietnam Pro" pitchFamily="34" charset="-122"/>
+                <a:cs typeface="Be Vietnam Pro" pitchFamily="34" charset="-120"/>
+              </a:rPr>
+              <a:t> cách</a:t>
+            </a:r>
+            <a:r>
+              <a:rPr lang="en-US" sz="2700" dirty="0" spc="-15" kern="0">
+                <a:solidFill>
+                  <a:srgbClr val="F3EEE3"/>
+                </a:solidFill>
+                <a:latin typeface="Be Vietnam Pro" pitchFamily="34" charset="0"/>
+                <a:ea typeface="Be Vietnam Pro" pitchFamily="34" charset="-122"/>
+                <a:cs typeface="Be Vietnam Pro" pitchFamily="34" charset="-120"/>
+              </a:rPr>
+              <a:t> gọi</a:t>
+            </a:r>
+            <a:r>
+              <a:rPr lang="en-US" sz="2700" dirty="0" spc="-4" kern="0">
+                <a:solidFill>
+                  <a:srgbClr val="F3EEE3"/>
+                </a:solidFill>
+                <a:latin typeface="Be Vietnam Pro" pitchFamily="34" charset="0"/>
+                <a:ea typeface="Be Vietnam Pro" pitchFamily="34" charset="-122"/>
+                <a:cs typeface="Be Vietnam Pro" pitchFamily="34" charset="-120"/>
+              </a:rPr>
+              <a:t> ở</a:t>
+            </a:r>
+            <a:r>
+              <a:rPr lang="en-US" sz="2700" dirty="0" spc="-13" kern="0">
+                <a:solidFill>
+                  <a:srgbClr val="F3EEE3"/>
+                </a:solidFill>
+                <a:latin typeface="Be Vietnam Pro" pitchFamily="34" charset="0"/>
+                <a:ea typeface="Be Vietnam Pro" pitchFamily="34" charset="-122"/>
+                <a:cs typeface="Be Vietnam Pro" pitchFamily="34" charset="-120"/>
+              </a:rPr>
+              <a:t> ngôn</a:t>
+            </a:r>
+            <a:r>
+              <a:rPr lang="en-US" sz="2700" dirty="0" spc="-4" kern="0">
+                <a:solidFill>
+                  <a:srgbClr val="F3EEE3"/>
+                </a:solidFill>
+                <a:latin typeface="Be Vietnam Pro" pitchFamily="34" charset="0"/>
+                <a:ea typeface="Be Vietnam Pro" pitchFamily="34" charset="-122"/>
+                <a:cs typeface="Be Vietnam Pro" pitchFamily="34" charset="-120"/>
+              </a:rPr>
+              <a:t> ngữ</a:t>
+            </a:r>
+            <a:r>
+              <a:rPr lang="en-US" sz="2700" dirty="0" spc="0" kern="0">
+                <a:solidFill>
+                  <a:srgbClr val="F3EEE3"/>
+                </a:solidFill>
+                <a:latin typeface="Be Vietnam Pro" pitchFamily="34" charset="0"/>
+                <a:ea typeface="Be Vietnam Pro" pitchFamily="34" charset="-122"/>
+                <a:cs typeface="Be Vietnam Pro" pitchFamily="34" charset="-120"/>
+              </a:rPr>
+              <a:t> khác</a:t>
+            </a:r>
+            <a:r>
+              <a:rPr lang="en-US" sz="2700" dirty="0" spc="-2" kern="0">
+                <a:solidFill>
+                  <a:srgbClr val="F3EEE3"/>
+                </a:solidFill>
+                <a:latin typeface="Be Vietnam Pro" pitchFamily="34" charset="0"/>
+                <a:ea typeface="Be Vietnam Pro" pitchFamily="34" charset="-122"/>
+                <a:cs typeface="Be Vietnam Pro" pitchFamily="34" charset="-120"/>
+              </a:rPr>
+              <a:t> (kiến</a:t>
+            </a:r>
+            <a:r>
+              <a:rPr lang="en-US" sz="2700" dirty="0" spc="8" kern="0">
+                <a:solidFill>
+                  <a:srgbClr val="F3EEE3"/>
+                </a:solidFill>
+                <a:latin typeface="Be Vietnam Pro" pitchFamily="34" charset="0"/>
+                <a:ea typeface="Be Vietnam Pro" pitchFamily="34" charset="-122"/>
+                <a:cs typeface="Be Vietnam Pro" pitchFamily="34" charset="-120"/>
+              </a:rPr>
+              <a:t> thức</a:t>
             </a:r>
             <a:r>
               <a:rPr lang="en-US" sz="2700" dirty="0" spc="-1" kern="0">
@@ -12234,62 +12300,7 @@
                 <a:ea typeface="Be Vietnam Pro" pitchFamily="34" charset="-122"/>
                 <a:cs typeface="Be Vietnam Pro" pitchFamily="34" charset="-120"/>
               </a:rPr>
-              <a:t> dài</a:t>
-            </a:r>
-            <a:r>
-              <a:rPr lang="en-US" sz="2700" dirty="0" spc="9" kern="0">
-                <a:solidFill>
-                  <a:srgbClr val="F3EEE3"/>
-                </a:solidFill>
-                <a:latin typeface="Be Vietnam Pro" pitchFamily="34" charset="0"/>
-                <a:ea typeface="Be Vietnam Pro" pitchFamily="34" charset="-122"/>
-                <a:cs typeface="Be Vietnam Pro" pitchFamily="34" charset="-120"/>
-              </a:rPr>
-              <a:t> đồng</a:t>
-            </a:r>
-            <a:r>
-              <a:rPr lang="en-US" sz="2700" dirty="0" spc="1" kern="0">
-                <a:solidFill>
-                  <a:srgbClr val="F3EEE3"/>
-                </a:solidFill>
-                <a:latin typeface="Be Vietnam Pro" pitchFamily="34" charset="0"/>
-                <a:ea typeface="Be Vietnam Pro" pitchFamily="34" charset="-122"/>
-                <a:cs typeface="Be Vietnam Pro" pitchFamily="34" charset="-120"/>
-              </a:rPr>
-              <a:t> thời,</a:t>
-            </a:r>
-            <a:r>
-              <a:rPr lang="en-US" sz="2700" dirty="0" spc="-2" kern="0">
-                <a:solidFill>
-                  <a:srgbClr val="F3EEE3"/>
-                </a:solidFill>
-                <a:latin typeface="Be Vietnam Pro" pitchFamily="34" charset="0"/>
-                <a:ea typeface="Be Vietnam Pro" pitchFamily="34" charset="-122"/>
-                <a:cs typeface="Be Vietnam Pro" pitchFamily="34" charset="-120"/>
-              </a:rPr>
-              <a:t> không</a:t>
-            </a:r>
-            <a:r>
-              <a:rPr lang="en-US" sz="2700" dirty="0" spc="-1" kern="0">
-                <a:solidFill>
-                  <a:srgbClr val="F3EEE3"/>
-                </a:solidFill>
-                <a:latin typeface="Be Vietnam Pro" pitchFamily="34" charset="0"/>
-                <a:ea typeface="Be Vietnam Pro" pitchFamily="34" charset="-122"/>
-                <a:cs typeface="Be Vietnam Pro" pitchFamily="34" charset="-120"/>
-              </a:rPr>
-              <a:t> chặn luồng</a:t>
-            </a:r>
-            <a:r>
-              <a:rPr lang="en-US" sz="2700" dirty="0" spc="-2" kern="0">
-                <a:solidFill>
-                  <a:srgbClr val="F3EEE3"/>
-                </a:solidFill>
-                <a:latin typeface="Be Vietnam Pro" pitchFamily="34" charset="0"/>
-                <a:ea typeface="Be Vietnam Pro" pitchFamily="34" charset="-122"/>
-                <a:cs typeface="Be Vietnam Pro" pitchFamily="34" charset="-120"/>
-              </a:rPr>
-              <a:t> chính.</a:t>
+              <a:t> chung).</a:t>
             </a:r>
             <a:endParaRPr lang="en-US" sz="2700" dirty="0"/>
           </a:p>
@@ -12342,7 +12353,7 @@
               <a:buNone/>
             </a:pPr>
             <a:r>
-              <a:rPr lang="en-US" sz="1800" b="1" spc="216" kern="0" dirty="0">
+              <a:rPr lang="en-US" sz="1800" b="1" spc="225" kern="0" dirty="0">
                 <a:solidFill>
                   <a:srgbClr val="9AA0B5"/>
                 </a:solidFill>
@@ -12350,10 +12361,10 @@
                 <a:ea typeface="Be Vietnam Pro" pitchFamily="34" charset="-122"/>
                 <a:cs typeface="Be Vietnam Pro" pitchFamily="34" charset="-120"/>
               </a:rPr>
-              <a:t>PROMISE</a:t>
-            </a:r>
-            <a:r>
-              <a:rPr lang="en-US" sz="1800" b="1" spc="225" kern="0" dirty="0">
+              <a:t>FUTURE:</a:t>
+            </a:r>
+            <a:r>
+              <a:rPr lang="en-US" sz="1800" b="1" spc="226" kern="0" dirty="0">
                 <a:solidFill>
                   <a:srgbClr val="9AA0B5"/>
                 </a:solidFill>
@@ -12361,7 +12372,18 @@
                 <a:ea typeface="Be Vietnam Pro" pitchFamily="34" charset="-122"/>
                 <a:cs typeface="Be Vietnam Pro" pitchFamily="34" charset="-120"/>
               </a:rPr>
-              <a:t> GIỮ, FUTURE</a:t>
+              <a:t> NHẬN</a:t>
+            </a:r>
+            <a:r>
+              <a:rPr lang="en-US" sz="1800" b="1" spc="219" kern="0" dirty="0">
+                <a:solidFill>
+                  <a:srgbClr val="9AA0B5"/>
+                </a:solidFill>
+                <a:latin typeface="Be Vietnam Pro" pitchFamily="34" charset="0"/>
+                <a:ea typeface="Be Vietnam Pro" pitchFamily="34" charset="-122"/>
+                <a:cs typeface="Be Vietnam Pro" pitchFamily="34" charset="-120"/>
+              </a:rPr>
+              <a:t> TRƯỚC,</a:t>
             </a:r>
             <a:r>
               <a:rPr lang="en-US" sz="1800" b="1" spc="180" kern="0" dirty="0">
@@ -12373,6 +12395,17 @@
                 <a:cs typeface="Be Vietnam Pro" pitchFamily="34" charset="-120"/>
               </a:rPr>
               <a:t> LẤY</a:t>
+            </a:r>
+            <a:r>
+              <a:rPr lang="en-US" sz="1800" b="1" spc="214" kern="0" dirty="0">
+                <a:solidFill>
+                  <a:srgbClr val="9AA0B5"/>
+                </a:solidFill>
+                <a:latin typeface="Be Vietnam Pro" pitchFamily="34" charset="0"/>
+                <a:ea typeface="Be Vietnam Pro" pitchFamily="34" charset="-122"/>
+                <a:cs typeface="Be Vietnam Pro" pitchFamily="34" charset="-120"/>
+              </a:rPr>
+              <a:t> SAU</a:t>
             </a:r>
             <a:endParaRPr lang="en-US" sz="1800" dirty="0"/>
           </a:p>
@@ -13634,7 +13667,7 @@
               <a:buNone/>
             </a:pPr>
             <a:r>
-              <a:rPr lang="en-US" sz="3300" b="1" dirty="0" spc="6" kern="0">
+              <a:rPr lang="en-US" sz="3300" b="1" dirty="0" spc="-3" kern="0">
                 <a:solidFill>
                   <a:srgbClr val="0F766E"/>
                 </a:solidFill>
@@ -13642,7 +13675,29 @@
                 <a:ea typeface="Be Vietnam Pro" pitchFamily="34" charset="-122"/>
                 <a:cs typeface="Be Vietnam Pro" pitchFamily="34" charset="-120"/>
               </a:rPr>
-              <a:t>Bảo</a:t>
+              <a:t>Hai</a:t>
+            </a:r>
+            <a:r>
+              <a:rPr lang="en-US" sz="3300" b="1" dirty="0" spc="-1" kern="0">
+                <a:solidFill>
+                  <a:srgbClr val="0F766E"/>
+                </a:solidFill>
+                <a:latin typeface="Be Vietnam Pro" pitchFamily="34" charset="0"/>
+                <a:ea typeface="Be Vietnam Pro" pitchFamily="34" charset="-122"/>
+                <a:cs typeface="Be Vietnam Pro" pitchFamily="34" charset="-120"/>
+              </a:rPr>
+              <a:t> cách</a:t>
+            </a:r>
+            <a:r>
+              <a:rPr lang="en-US" sz="3300" b="1" dirty="0" spc="0" kern="0">
+                <a:solidFill>
+                  <a:srgbClr val="0F766E"/>
+                </a:solidFill>
+                <a:latin typeface="Be Vietnam Pro" pitchFamily="34" charset="0"/>
+                <a:ea typeface="Be Vietnam Pro" pitchFamily="34" charset="-122"/>
+                <a:cs typeface="Be Vietnam Pro" pitchFamily="34" charset="-120"/>
+              </a:rPr>
+              <a:t> bảo</a:t>
             </a:r>
             <a:r>
               <a:rPr lang="en-US" sz="3300" b="1" dirty="0" spc="-30" kern="0">
@@ -13656,7 +13711,7 @@
               <a:t> vệ</a:t>
             </a:r>
             <a:r>
-              <a:rPr lang="en-US" sz="3300" b="1" dirty="0" spc="-5" kern="0">
+              <a:rPr lang="en-US" sz="3300" b="1" dirty="0" spc="-1" kern="0">
                 <a:solidFill>
                   <a:srgbClr val="0F766E"/>
                 </a:solidFill>
@@ -13664,10 +13719,10 @@
                 <a:ea typeface="Be Vietnam Pro" pitchFamily="34" charset="-122"/>
                 <a:cs typeface="Be Vietnam Pro" pitchFamily="34" charset="-120"/>
               </a:rPr>
-              <a:t> tài</a:t>
-            </a:r>
-            <a:r>
-              <a:rPr lang="en-US" sz="3300" b="1" dirty="0" spc="-22" kern="0">
+              <a:t> dữ</a:t>
+            </a:r>
+            <a:r>
+              <a:rPr lang="en-US" sz="3300" b="1" dirty="0" spc="0" kern="0">
                 <a:solidFill>
                   <a:srgbClr val="0F766E"/>
                 </a:solidFill>
@@ -13675,10 +13730,10 @@
                 <a:ea typeface="Be Vietnam Pro" pitchFamily="34" charset="-122"/>
                 <a:cs typeface="Be Vietnam Pro" pitchFamily="34" charset="-120"/>
               </a:rPr>
-              <a:t> nguyên</a:t>
-            </a:r>
-            <a:r>
-              <a:rPr lang="en-US" sz="3300" b="1" dirty="0" spc="-2" kern="0">
+              <a:t> liệu</a:t>
+            </a:r>
+            <a:r>
+              <a:rPr lang="en-US" sz="3300" b="1" dirty="0" spc="-4" kern="0">
                 <a:solidFill>
                   <a:srgbClr val="0F766E"/>
                 </a:solidFill>
@@ -13686,18 +13741,7 @@
                 <a:ea typeface="Be Vietnam Pro" pitchFamily="34" charset="-122"/>
                 <a:cs typeface="Be Vietnam Pro" pitchFamily="34" charset="-120"/>
               </a:rPr>
-              <a:t> chia</a:t>
-            </a:r>
-            <a:r>
-              <a:rPr lang="en-US" sz="3300" b="1" dirty="0" spc="-6" kern="0">
-                <a:solidFill>
-                  <a:srgbClr val="0F766E"/>
-                </a:solidFill>
-                <a:latin typeface="Be Vietnam Pro" pitchFamily="34" charset="0"/>
-                <a:ea typeface="Be Vietnam Pro" pitchFamily="34" charset="-122"/>
-                <a:cs typeface="Be Vietnam Pro" pitchFamily="34" charset="-120"/>
-              </a:rPr>
-              <a:t> sẻ</a:t>
+              <a:t> chung</a:t>
             </a:r>
             <a:endParaRPr lang="en-US" sz="3300" dirty="0"/>
           </a:p>
@@ -13731,26 +13775,48 @@
               <a:buNone/>
             </a:pPr>
             <a:r>
-              <a:rPr lang="en-US" sz="2700" dirty="0" spc="-60" kern="0">
-                <a:solidFill>
-                  <a:srgbClr val="14161C"/>
-                </a:solidFill>
-                <a:latin typeface="Be Vietnam Pro" pitchFamily="34" charset="0"/>
-                <a:ea typeface="Be Vietnam Pro" pitchFamily="34" charset="-122"/>
-                <a:cs typeface="Be Vietnam Pro" pitchFamily="34" charset="-120"/>
-              </a:rPr>
-              <a:t>Tránh</a:t>
-            </a:r>
-            <a:r>
-              <a:rPr lang="en-US" sz="2700" dirty="0" spc="-22" kern="0">
-                <a:solidFill>
-                  <a:srgbClr val="14161C"/>
-                </a:solidFill>
-                <a:latin typeface="Be Vietnam Pro" pitchFamily="34" charset="0"/>
-                <a:ea typeface="Be Vietnam Pro" pitchFamily="34" charset="-122"/>
-                <a:cs typeface="Be Vietnam Pro" pitchFamily="34" charset="-120"/>
-              </a:rPr>
-              <a:t> race</a:t>
+              <a:rPr lang="en-US" sz="2700" dirty="0" spc="-8" kern="0">
+                <a:solidFill>
+                  <a:srgbClr val="14161C"/>
+                </a:solidFill>
+                <a:latin typeface="Be Vietnam Pro" pitchFamily="34" charset="0"/>
+                <a:ea typeface="Be Vietnam Pro" pitchFamily="34" charset="-122"/>
+                <a:cs typeface="Be Vietnam Pro" pitchFamily="34" charset="-120"/>
+              </a:rPr>
+              <a:t>Monitor:</a:t>
+            </a:r>
+            <a:r>
+              <a:rPr lang="en-US" sz="2700" dirty="0" spc="-2" kern="0">
+                <a:solidFill>
+                  <a:srgbClr val="14161C"/>
+                </a:solidFill>
+                <a:latin typeface="Be Vietnam Pro" pitchFamily="34" charset="0"/>
+                <a:ea typeface="Be Vietnam Pro" pitchFamily="34" charset="-122"/>
+                <a:cs typeface="Be Vietnam Pro" pitchFamily="34" charset="-120"/>
+              </a:rPr>
+              <a:t> mỗi</a:t>
+            </a:r>
+            <a:r>
+              <a:rPr lang="en-US" sz="2700" dirty="0" spc="0" kern="0">
+                <a:solidFill>
+                  <a:srgbClr val="14161C"/>
+                </a:solidFill>
+                <a:latin typeface="Be Vietnam Pro" pitchFamily="34" charset="0"/>
+                <a:ea typeface="Be Vietnam Pro" pitchFamily="34" charset="-122"/>
+                <a:cs typeface="Be Vietnam Pro" pitchFamily="34" charset="-120"/>
+              </a:rPr>
+              <a:t> lúc</a:t>
+            </a:r>
+            <a:r>
+              <a:rPr lang="en-US" sz="2700" dirty="0" spc="-7" kern="0">
+                <a:solidFill>
+                  <a:srgbClr val="14161C"/>
+                </a:solidFill>
+                <a:latin typeface="Be Vietnam Pro" pitchFamily="34" charset="0"/>
+                <a:ea typeface="Be Vietnam Pro" pitchFamily="34" charset="-122"/>
+                <a:cs typeface="Be Vietnam Pro" pitchFamily="34" charset="-120"/>
+              </a:rPr>
+              <a:t> một</a:t>
             </a:r>
             <a:r>
               <a:rPr lang="en-US" sz="2700" dirty="0" spc="-1" kern="0">
@@ -13761,7 +13827,73 @@
                 <a:ea typeface="Be Vietnam Pro" pitchFamily="34" charset="-122"/>
                 <a:cs typeface="Be Vietnam Pro" pitchFamily="34" charset="-120"/>
               </a:rPr>
-              <a:t> condition khi</a:t>
+              <a:t> luồng</a:t>
+            </a:r>
+            <a:r>
+              <a:rPr lang="en-US" sz="2700" dirty="0" spc="-13" kern="0">
+                <a:solidFill>
+                  <a:srgbClr val="14161C"/>
+                </a:solidFill>
+                <a:latin typeface="Be Vietnam Pro" pitchFamily="34" charset="0"/>
+                <a:ea typeface="Be Vietnam Pro" pitchFamily="34" charset="-122"/>
+                <a:cs typeface="Be Vietnam Pro" pitchFamily="34" charset="-120"/>
+              </a:rPr>
+              <a:t> sở</a:t>
+            </a:r>
+            <a:r>
+              <a:rPr lang="en-US" sz="2700" dirty="0" spc="15" kern="0">
+                <a:solidFill>
+                  <a:srgbClr val="14161C"/>
+                </a:solidFill>
+                <a:latin typeface="Be Vietnam Pro" pitchFamily="34" charset="0"/>
+                <a:ea typeface="Be Vietnam Pro" pitchFamily="34" charset="-122"/>
+                <a:cs typeface="Be Vietnam Pro" pitchFamily="34" charset="-120"/>
+              </a:rPr>
+              <a:t> hữu.</a:t>
+            </a:r>
+            <a:r>
+              <a:rPr lang="en-US" sz="2700" dirty="0" spc="-6" kern="0">
+                <a:solidFill>
+                  <a:srgbClr val="14161C"/>
+                </a:solidFill>
+                <a:latin typeface="Be Vietnam Pro" pitchFamily="34" charset="0"/>
+                <a:ea typeface="Be Vietnam Pro" pitchFamily="34" charset="-122"/>
+                <a:cs typeface="Be Vietnam Pro" pitchFamily="34" charset="-120"/>
+              </a:rPr>
+              <a:t> Khóa</a:t>
+            </a:r>
+            <a:r>
+              <a:rPr lang="en-US" sz="2700" dirty="0" spc="4" kern="0">
+                <a:solidFill>
+                  <a:srgbClr val="14161C"/>
+                </a:solidFill>
+                <a:latin typeface="Be Vietnam Pro" pitchFamily="34" charset="0"/>
+                <a:ea typeface="Be Vietnam Pro" pitchFamily="34" charset="-122"/>
+                <a:cs typeface="Be Vietnam Pro" pitchFamily="34" charset="-120"/>
+              </a:rPr>
+              <a:t> đọc-ghi:</a:t>
+            </a:r>
+            <a:r>
+              <a:rPr lang="en-US" sz="2700" dirty="0" spc="10" kern="0">
+                <a:solidFill>
+                  <a:srgbClr val="14161C"/>
+                </a:solidFill>
+                <a:latin typeface="Be Vietnam Pro" pitchFamily="34" charset="0"/>
+                <a:ea typeface="Be Vietnam Pro" pitchFamily="34" charset="-122"/>
+                <a:cs typeface="Be Vietnam Pro" pitchFamily="34" charset="-120"/>
+              </a:rPr>
+              <a:t> đọc</a:t>
+            </a:r>
+            <a:r>
+              <a:rPr lang="en-US" sz="2700" dirty="0" spc="1" kern="0">
+                <a:solidFill>
+                  <a:srgbClr val="14161C"/>
+                </a:solidFill>
+                <a:latin typeface="Be Vietnam Pro" pitchFamily="34" charset="0"/>
+                <a:ea typeface="Be Vietnam Pro" pitchFamily="34" charset="-122"/>
+                <a:cs typeface="Be Vietnam Pro" pitchFamily="34" charset="-120"/>
+              </a:rPr>
+              <a:t> chung,</a:t>
             </a:r>
             <a:r>
               <a:rPr lang="en-US" sz="2700" dirty="0" spc="-2" kern="0">
@@ -13772,62 +13904,18 @@
                 <a:ea typeface="Be Vietnam Pro" pitchFamily="34" charset="-122"/>
                 <a:cs typeface="Be Vietnam Pro" pitchFamily="34" charset="-120"/>
               </a:rPr>
-              <a:t> nhiều</a:t>
-            </a:r>
-            <a:r>
-              <a:rPr lang="en-US" sz="2700" dirty="0" spc="-1" kern="0">
-                <a:solidFill>
-                  <a:srgbClr val="14161C"/>
-                </a:solidFill>
-                <a:latin typeface="Be Vietnam Pro" pitchFamily="34" charset="0"/>
-                <a:ea typeface="Be Vietnam Pro" pitchFamily="34" charset="-122"/>
-                <a:cs typeface="Be Vietnam Pro" pitchFamily="34" charset="-120"/>
-              </a:rPr>
-              <a:t> luồng</a:t>
-            </a:r>
-            <a:r>
-              <a:rPr lang="en-US" sz="2700" dirty="0" spc="0" kern="0">
-                <a:solidFill>
-                  <a:srgbClr val="14161C"/>
-                </a:solidFill>
-                <a:latin typeface="Be Vietnam Pro" pitchFamily="34" charset="0"/>
-                <a:ea typeface="Be Vietnam Pro" pitchFamily="34" charset="-122"/>
-                <a:cs typeface="Be Vietnam Pro" pitchFamily="34" charset="-120"/>
-              </a:rPr>
-              <a:t> truy cập</a:t>
-            </a:r>
-            <a:r>
-              <a:rPr lang="en-US" sz="2700" dirty="0" spc="-1" kern="0">
-                <a:solidFill>
-                  <a:srgbClr val="14161C"/>
-                </a:solidFill>
-                <a:latin typeface="Be Vietnam Pro" pitchFamily="34" charset="0"/>
-                <a:ea typeface="Be Vietnam Pro" pitchFamily="34" charset="-122"/>
-                <a:cs typeface="Be Vietnam Pro" pitchFamily="34" charset="-120"/>
-              </a:rPr>
-              <a:t> cùng</a:t>
-            </a:r>
-            <a:r>
-              <a:rPr lang="en-US" sz="2700" dirty="0" spc="-4" kern="0">
-                <a:solidFill>
-                  <a:srgbClr val="14161C"/>
-                </a:solidFill>
-                <a:latin typeface="Be Vietnam Pro" pitchFamily="34" charset="0"/>
-                <a:ea typeface="Be Vietnam Pro" pitchFamily="34" charset="-122"/>
-                <a:cs typeface="Be Vietnam Pro" pitchFamily="34" charset="-120"/>
-              </a:rPr>
-              <a:t> dữ</a:t>
-            </a:r>
-            <a:r>
-              <a:rPr lang="en-US" sz="2700" dirty="0" spc="-1" kern="0">
-                <a:solidFill>
-                  <a:srgbClr val="14161C"/>
-                </a:solidFill>
-                <a:latin typeface="Be Vietnam Pro" pitchFamily="34" charset="0"/>
-                <a:ea typeface="Be Vietnam Pro" pitchFamily="34" charset="-122"/>
-                <a:cs typeface="Be Vietnam Pro" pitchFamily="34" charset="-120"/>
-              </a:rPr>
-              <a:t> liệu.</a:t>
+              <a:t> ghi</a:t>
+            </a:r>
+            <a:r>
+              <a:rPr lang="en-US" sz="2700" dirty="0" spc="5" kern="0">
+                <a:solidFill>
+                  <a:srgbClr val="14161C"/>
+                </a:solidFill>
+                <a:latin typeface="Be Vietnam Pro" pitchFamily="34" charset="0"/>
+                <a:ea typeface="Be Vietnam Pro" pitchFamily="34" charset="-122"/>
+                <a:cs typeface="Be Vietnam Pro" pitchFamily="34" charset="-120"/>
+              </a:rPr>
+              <a:t> riêng.</a:t>
             </a:r>
             <a:endParaRPr lang="en-US" sz="2700" dirty="0"/>
           </a:p>
@@ -14085,15 +14173,59 @@
               <a:buNone/>
             </a:pPr>
             <a:r>
-              <a:rPr lang="en-US" sz="2700" dirty="0" spc="-3" kern="0">
-                <a:solidFill>
-                  <a:srgbClr val="14161C"/>
-                </a:solidFill>
-                <a:latin typeface="Be Vietnam Pro" pitchFamily="34" charset="0"/>
-                <a:ea typeface="Be Vietnam Pro" pitchFamily="34" charset="-122"/>
-                <a:cs typeface="Be Vietnam Pro" pitchFamily="34" charset="-120"/>
-              </a:rPr>
-              <a:t>Đọc</a:t>
+              <a:rPr lang="en-US" sz="2700" dirty="0" spc="0" kern="0">
+                <a:solidFill>
+                  <a:srgbClr val="14161C"/>
+                </a:solidFill>
+                <a:latin typeface="Be Vietnam Pro" pitchFamily="34" charset="0"/>
+                <a:ea typeface="Be Vietnam Pro" pitchFamily="34" charset="-122"/>
+                <a:cs typeface="Be Vietnam Pro" pitchFamily="34" charset="-120"/>
+              </a:rPr>
+              <a:t>Ghi là</a:t>
+            </a:r>
+            <a:r>
+              <a:rPr lang="en-US" sz="2700" dirty="0" spc="9" kern="0">
+                <a:solidFill>
+                  <a:srgbClr val="14161C"/>
+                </a:solidFill>
+                <a:latin typeface="Be Vietnam Pro" pitchFamily="34" charset="0"/>
+                <a:ea typeface="Be Vietnam Pro" pitchFamily="34" charset="-122"/>
+                <a:cs typeface="Be Vietnam Pro" pitchFamily="34" charset="-120"/>
+              </a:rPr>
+              <a:t> độc</a:t>
+            </a:r>
+            <a:r>
+              <a:rPr lang="en-US" sz="2700" dirty="0" spc="-14" kern="0">
+                <a:solidFill>
+                  <a:srgbClr val="14161C"/>
+                </a:solidFill>
+                <a:latin typeface="Be Vietnam Pro" pitchFamily="34" charset="0"/>
+                <a:ea typeface="Be Vietnam Pro" pitchFamily="34" charset="-122"/>
+                <a:cs typeface="Be Vietnam Pro" pitchFamily="34" charset="-120"/>
+              </a:rPr>
+              <a:t> quyền;</a:t>
+            </a:r>
+            <a:r>
+              <a:rPr lang="en-US" sz="2700" dirty="0" spc="10" kern="0">
+                <a:solidFill>
+                  <a:srgbClr val="14161C"/>
+                </a:solidFill>
+                <a:latin typeface="Be Vietnam Pro" pitchFamily="34" charset="0"/>
+                <a:ea typeface="Be Vietnam Pro" pitchFamily="34" charset="-122"/>
+                <a:cs typeface="Be Vietnam Pro" pitchFamily="34" charset="-120"/>
+              </a:rPr>
+              <a:t> đọc</a:t>
+            </a:r>
+            <a:r>
+              <a:rPr lang="en-US" sz="2700" dirty="0" spc="9" kern="0">
+                <a:solidFill>
+                  <a:srgbClr val="14161C"/>
+                </a:solidFill>
+                <a:latin typeface="Be Vietnam Pro" pitchFamily="34" charset="0"/>
+                <a:ea typeface="Be Vietnam Pro" pitchFamily="34" charset="-122"/>
+                <a:cs typeface="Be Vietnam Pro" pitchFamily="34" charset="-120"/>
+              </a:rPr>
+              <a:t> được</a:t>
             </a:r>
             <a:r>
               <a:rPr lang="en-US" sz="2700" dirty="0" spc="-1" kern="0">
@@ -14104,18 +14236,29 @@
                 <a:ea typeface="Be Vietnam Pro" pitchFamily="34" charset="-122"/>
                 <a:cs typeface="Be Vietnam Pro" pitchFamily="34" charset="-120"/>
               </a:rPr>
-              <a:t> nhiều</a:t>
-            </a:r>
-            <a:r>
-              <a:rPr lang="en-US" sz="2700" dirty="0" spc="-4" kern="0">
-                <a:solidFill>
-                  <a:srgbClr val="14161C"/>
-                </a:solidFill>
-                <a:latin typeface="Be Vietnam Pro" pitchFamily="34" charset="0"/>
-                <a:ea typeface="Be Vietnam Pro" pitchFamily="34" charset="-122"/>
-                <a:cs typeface="Be Vietnam Pro" pitchFamily="34" charset="-120"/>
-              </a:rPr>
-              <a:t> hơn</a:t>
+              <a:t> chia</a:t>
+            </a:r>
+            <a:r>
+              <a:rPr lang="en-US" sz="2700" dirty="0" spc="-14" kern="0">
+                <a:solidFill>
+                  <a:srgbClr val="14161C"/>
+                </a:solidFill>
+                <a:latin typeface="Be Vietnam Pro" pitchFamily="34" charset="0"/>
+                <a:ea typeface="Be Vietnam Pro" pitchFamily="34" charset="-122"/>
+                <a:cs typeface="Be Vietnam Pro" pitchFamily="34" charset="-120"/>
+              </a:rPr>
+              <a:t> sẻ</a:t>
+            </a:r>
+            <a:r>
+              <a:rPr lang="en-US" sz="2700" dirty="0" spc="-2" kern="0">
+                <a:solidFill>
+                  <a:srgbClr val="14161C"/>
+                </a:solidFill>
+                <a:latin typeface="Be Vietnam Pro" pitchFamily="34" charset="0"/>
+                <a:ea typeface="Be Vietnam Pro" pitchFamily="34" charset="-122"/>
+                <a:cs typeface="Be Vietnam Pro" pitchFamily="34" charset="-120"/>
+              </a:rPr>
+              <a:t> nếu không</a:t>
             </a:r>
             <a:r>
               <a:rPr lang="en-US" sz="2700" dirty="0" spc="-1" kern="0">
@@ -14126,7 +14269,7 @@
                 <a:ea typeface="Be Vietnam Pro" pitchFamily="34" charset="-122"/>
                 <a:cs typeface="Be Vietnam Pro" pitchFamily="34" charset="-120"/>
               </a:rPr>
-              <a:t> ghi thì</a:t>
+              <a:t> có</a:t>
             </a:r>
             <a:r>
               <a:rPr lang="en-US" sz="2700" dirty="0" spc="-2" kern="0">
@@ -14137,29 +14280,7 @@
                 <a:ea typeface="Be Vietnam Pro" pitchFamily="34" charset="-122"/>
                 <a:cs typeface="Be Vietnam Pro" pitchFamily="34" charset="-120"/>
               </a:rPr>
-              <a:t> hợp</a:t>
-            </a:r>
-            <a:r>
-              <a:rPr lang="en-US" sz="2700" dirty="0" spc="-13" kern="0">
-                <a:solidFill>
-                  <a:srgbClr val="14161C"/>
-                </a:solidFill>
-                <a:latin typeface="Be Vietnam Pro" pitchFamily="34" charset="0"/>
-                <a:ea typeface="Be Vietnam Pro" pitchFamily="34" charset="-122"/>
-                <a:cs typeface="Be Vietnam Pro" pitchFamily="34" charset="-120"/>
-              </a:rPr>
-              <a:t> Read-write</a:t>
-            </a:r>
-            <a:r>
-              <a:rPr lang="en-US" sz="2700" dirty="0" spc="-3" kern="0">
-                <a:solidFill>
-                  <a:srgbClr val="14161C"/>
-                </a:solidFill>
-                <a:latin typeface="Be Vietnam Pro" pitchFamily="34" charset="0"/>
-                <a:ea typeface="Be Vietnam Pro" pitchFamily="34" charset="-122"/>
-                <a:cs typeface="Be Vietnam Pro" pitchFamily="34" charset="-120"/>
-              </a:rPr>
-              <a:t> lock.</a:t>
+              <a:t> ghi.</a:t>
             </a:r>
             <a:endParaRPr lang="en-US" sz="2700" dirty="0"/>
           </a:p>
@@ -15944,18 +16065,62 @@
               <a:t> luồng</a:t>
             </a:r>
             <a:r>
-              <a:rPr lang="en-US" sz="2700" dirty="0" spc="-8" kern="0">
-                <a:solidFill>
-                  <a:srgbClr val="F3EEE3"/>
-                </a:solidFill>
-                <a:latin typeface="Be Vietnam Pro" pitchFamily="34" charset="0"/>
-                <a:ea typeface="Be Vietnam Pro" pitchFamily="34" charset="-122"/>
-                <a:cs typeface="Be Vietnam Pro" pitchFamily="34" charset="-120"/>
-              </a:rPr>
-              <a:t> chạy</a:t>
-            </a:r>
-            <a:r>
-              <a:rPr lang="en-US" sz="2700" dirty="0" spc="-13" kern="0">
+              <a:rPr lang="en-US" sz="2700" dirty="0" spc="-15" kern="0">
+                <a:solidFill>
+                  <a:srgbClr val="F3EEE3"/>
+                </a:solidFill>
+                <a:latin typeface="Be Vietnam Pro" pitchFamily="34" charset="0"/>
+                <a:ea typeface="Be Vietnam Pro" pitchFamily="34" charset="-122"/>
+                <a:cs typeface="Be Vietnam Pro" pitchFamily="34" charset="-120"/>
+              </a:rPr>
+              <a:t> gọi</a:t>
+            </a:r>
+            <a:r>
+              <a:rPr lang="en-US" sz="2700" dirty="0" spc="-11" kern="0">
+                <a:solidFill>
+                  <a:srgbClr val="F3EEE3"/>
+                </a:solidFill>
+                <a:latin typeface="Be Vietnam Pro" pitchFamily="34" charset="0"/>
+                <a:ea typeface="Be Vietnam Pro" pitchFamily="34" charset="-122"/>
+                <a:cs typeface="Be Vietnam Pro" pitchFamily="34" charset="-120"/>
+              </a:rPr>
+              <a:t> wait</a:t>
+            </a:r>
+            <a:r>
+              <a:rPr lang="en-US" sz="2700" dirty="0" spc="-18" kern="0">
+                <a:solidFill>
+                  <a:srgbClr val="F3EEE3"/>
+                </a:solidFill>
+                <a:latin typeface="Be Vietnam Pro" pitchFamily="34" charset="0"/>
+                <a:ea typeface="Be Vietnam Pro" pitchFamily="34" charset="-122"/>
+                <a:cs typeface="Be Vietnam Pro" pitchFamily="34" charset="-120"/>
+              </a:rPr>
+              <a:t> và</a:t>
+            </a:r>
+            <a:r>
+              <a:rPr lang="en-US" sz="2700" dirty="0" spc="-4" kern="0">
+                <a:solidFill>
+                  <a:srgbClr val="F3EEE3"/>
+                </a:solidFill>
+                <a:latin typeface="Be Vietnam Pro" pitchFamily="34" charset="0"/>
+                <a:ea typeface="Be Vietnam Pro" pitchFamily="34" charset="-122"/>
+                <a:cs typeface="Be Vietnam Pro" pitchFamily="34" charset="-120"/>
+              </a:rPr>
+              <a:t> bị</a:t>
+            </a:r>
+            <a:r>
+              <a:rPr lang="en-US" sz="2700" dirty="0" spc="0" kern="0">
+                <a:solidFill>
+                  <a:srgbClr val="F3EEE3"/>
+                </a:solidFill>
+                <a:latin typeface="Be Vietnam Pro" pitchFamily="34" charset="0"/>
+                <a:ea typeface="Be Vietnam Pro" pitchFamily="34" charset="-122"/>
+                <a:cs typeface="Be Vietnam Pro" pitchFamily="34" charset="-120"/>
+              </a:rPr>
+              <a:t> chặn</a:t>
+            </a:r>
+            <a:r>
+              <a:rPr lang="en-US" sz="2700" dirty="0" spc="-14" kern="0">
                 <a:solidFill>
                   <a:srgbClr val="F3EEE3"/>
                 </a:solidFill>
@@ -15966,48 +16131,15 @@
               <a:t> tới</a:t>
             </a:r>
             <a:r>
-              <a:rPr lang="en-US" sz="2700" dirty="0" spc="19" kern="0">
-                <a:solidFill>
-                  <a:srgbClr val="F3EEE3"/>
-                </a:solidFill>
-                <a:latin typeface="Be Vietnam Pro" pitchFamily="34" charset="0"/>
-                <a:ea typeface="Be Vietnam Pro" pitchFamily="34" charset="-122"/>
-                <a:cs typeface="Be Vietnam Pro" pitchFamily="34" charset="-120"/>
-              </a:rPr>
-              <a:t> điểm</a:t>
-            </a:r>
-            <a:r>
-              <a:rPr lang="en-US" sz="2700" dirty="0" spc="-30" kern="0">
-                <a:solidFill>
-                  <a:srgbClr val="F3EEE3"/>
-                </a:solidFill>
-                <a:latin typeface="Be Vietnam Pro" pitchFamily="34" charset="0"/>
-                <a:ea typeface="Be Vietnam Pro" pitchFamily="34" charset="-122"/>
-                <a:cs typeface="Be Vietnam Pro" pitchFamily="34" charset="-120"/>
-              </a:rPr>
-              <a:t> rào</a:t>
-            </a:r>
-            <a:r>
-              <a:rPr lang="en-US" sz="2700" dirty="0" spc="-29" kern="0">
-                <a:solidFill>
-                  <a:srgbClr val="F3EEE3"/>
-                </a:solidFill>
-                <a:latin typeface="Be Vietnam Pro" pitchFamily="34" charset="0"/>
-                <a:ea typeface="Be Vietnam Pro" pitchFamily="34" charset="-122"/>
-                <a:cs typeface="Be Vietnam Pro" pitchFamily="34" charset="-120"/>
-              </a:rPr>
-              <a:t> rồi</a:t>
-            </a:r>
-            <a:r>
-              <a:rPr lang="en-US" sz="2700" dirty="0" spc="0" kern="0">
-                <a:solidFill>
-                  <a:srgbClr val="F3EEE3"/>
-                </a:solidFill>
-                <a:latin typeface="Be Vietnam Pro" pitchFamily="34" charset="0"/>
-                <a:ea typeface="Be Vietnam Pro" pitchFamily="34" charset="-122"/>
-                <a:cs typeface="Be Vietnam Pro" pitchFamily="34" charset="-120"/>
-              </a:rPr>
-              <a:t> chặn, chờ</a:t>
+              <a:rPr lang="en-US" sz="2700" dirty="0" spc="-1" kern="0">
+                <a:solidFill>
+                  <a:srgbClr val="F3EEE3"/>
+                </a:solidFill>
+                <a:latin typeface="Be Vietnam Pro" pitchFamily="34" charset="0"/>
+                <a:ea typeface="Be Vietnam Pro" pitchFamily="34" charset="-122"/>
+                <a:cs typeface="Be Vietnam Pro" pitchFamily="34" charset="-120"/>
+              </a:rPr>
+              <a:t> khi</a:t>
             </a:r>
             <a:r>
               <a:rPr lang="en-US" sz="2700" dirty="0" spc="-2" kern="0">
@@ -16029,18 +16161,40 @@
                 <a:ea typeface="Be Vietnam Pro" pitchFamily="34" charset="-122"/>
                 <a:cs typeface="Be Vietnam Pro" pitchFamily="34" charset="-120"/>
               </a:rPr>
-              <a:t> luồng cùng</a:t>
-            </a:r>
-            <a:r>
-              <a:rPr lang="en-US" sz="2700" dirty="0" spc="-12" kern="0">
-                <a:solidFill>
-                  <a:srgbClr val="F3EEE3"/>
-                </a:solidFill>
-                <a:latin typeface="Be Vietnam Pro" pitchFamily="34" charset="0"/>
-                <a:ea typeface="Be Vietnam Pro" pitchFamily="34" charset="-122"/>
-                <a:cs typeface="Be Vietnam Pro" pitchFamily="34" charset="-120"/>
-              </a:rPr>
-              <a:t> tới.</a:t>
+              <a:t> luồng</a:t>
+            </a:r>
+            <a:r>
+              <a:rPr lang="en-US" sz="2700" dirty="0" spc="16" kern="0">
+                <a:solidFill>
+                  <a:srgbClr val="F3EEE3"/>
+                </a:solidFill>
+                <a:latin typeface="Be Vietnam Pro" pitchFamily="34" charset="0"/>
+                <a:ea typeface="Be Vietnam Pro" pitchFamily="34" charset="-122"/>
+                <a:cs typeface="Be Vietnam Pro" pitchFamily="34" charset="-120"/>
+              </a:rPr>
+              <a:t> đã</a:t>
+            </a:r>
+            <a:r>
+              <a:rPr lang="en-US" sz="2700" dirty="0" spc="-15" kern="0">
+                <a:solidFill>
+                  <a:srgbClr val="F3EEE3"/>
+                </a:solidFill>
+                <a:latin typeface="Be Vietnam Pro" pitchFamily="34" charset="0"/>
+                <a:ea typeface="Be Vietnam Pro" pitchFamily="34" charset="-122"/>
+                <a:cs typeface="Be Vietnam Pro" pitchFamily="34" charset="-120"/>
+              </a:rPr>
+              <a:t> gọi</a:t>
+            </a:r>
+            <a:r>
+              <a:rPr lang="en-US" sz="2700" dirty="0" spc="-10" kern="0">
+                <a:solidFill>
+                  <a:srgbClr val="F3EEE3"/>
+                </a:solidFill>
+                <a:latin typeface="Be Vietnam Pro" pitchFamily="34" charset="0"/>
+                <a:ea typeface="Be Vietnam Pro" pitchFamily="34" charset="-122"/>
+                <a:cs typeface="Be Vietnam Pro" pitchFamily="34" charset="-120"/>
+              </a:rPr>
+              <a:t> wait.</a:t>
             </a:r>
             <a:endParaRPr lang="en-US" sz="2700" dirty="0"/>
           </a:p>
@@ -16075,6 +16229,28 @@
               <a:buNone/>
             </a:pPr>
             <a:r>
+              <a:rPr lang="en-US" sz="2250" b="1" dirty="0" spc="-4" kern="0">
+                <a:solidFill>
+                  <a:srgbClr val="14161C"/>
+                </a:solidFill>
+                <a:latin typeface="Be Vietnam Pro" pitchFamily="34" charset="0"/>
+                <a:ea typeface="Be Vietnam Pro" pitchFamily="34" charset="-122"/>
+                <a:cs typeface="Be Vietnam Pro" pitchFamily="34" charset="-120"/>
+              </a:rPr>
+              <a:t>số</a:t>
+            </a:r>
+            <a:r>
+              <a:rPr lang="en-US" sz="2250" b="1" dirty="0" spc="-5" kern="0">
+                <a:solidFill>
+                  <a:srgbClr val="14161C"/>
+                </a:solidFill>
+                <a:latin typeface="Be Vietnam Pro" pitchFamily="34" charset="0"/>
+                <a:ea typeface="Be Vietnam Pro" pitchFamily="34" charset="-122"/>
+                <a:cs typeface="Be Vietnam Pro" pitchFamily="34" charset="-120"/>
+              </a:rPr>
+              <a:t> luồng</a:t>
+            </a:r>
+            <a:r>
               <a:rPr lang="en-US" sz="2250" b="1" dirty="0" spc="0" kern="0">
                 <a:solidFill>
                   <a:srgbClr val="14161C"/>
@@ -16083,40 +16259,18 @@
                 <a:ea typeface="Be Vietnam Pro" pitchFamily="34" charset="-122"/>
                 <a:cs typeface="Be Vietnam Pro" pitchFamily="34" charset="-120"/>
               </a:rPr>
-              <a:t>tác</a:t>
-            </a:r>
-            <a:r>
-              <a:rPr lang="en-US" sz="2250" b="1" dirty="0" spc="2" kern="0">
-                <a:solidFill>
-                  <a:srgbClr val="14161C"/>
-                </a:solidFill>
-                <a:latin typeface="Be Vietnam Pro" pitchFamily="34" charset="0"/>
-                <a:ea typeface="Be Vietnam Pro" pitchFamily="34" charset="-122"/>
-                <a:cs typeface="Be Vietnam Pro" pitchFamily="34" charset="-120"/>
-              </a:rPr>
-              <a:t> vụ</a:t>
-            </a:r>
-            <a:r>
-              <a:rPr lang="en-US" sz="2250" b="1" dirty="0" spc="-8" kern="0">
-                <a:solidFill>
-                  <a:srgbClr val="14161C"/>
-                </a:solidFill>
-                <a:latin typeface="Be Vietnam Pro" pitchFamily="34" charset="0"/>
-                <a:ea typeface="Be Vietnam Pro" pitchFamily="34" charset="-122"/>
-                <a:cs typeface="Be Vietnam Pro" pitchFamily="34" charset="-120"/>
-              </a:rPr>
-              <a:t> song</a:t>
-            </a:r>
-            <a:r>
-              <a:rPr lang="en-US" sz="2250" b="1" dirty="0" spc="-7" kern="0">
-                <a:solidFill>
-                  <a:srgbClr val="14161C"/>
-                </a:solidFill>
-                <a:latin typeface="Be Vietnam Pro" pitchFamily="34" charset="0"/>
-                <a:ea typeface="Be Vietnam Pro" pitchFamily="34" charset="-122"/>
-                <a:cs typeface="Be Vietnam Pro" pitchFamily="34" charset="-120"/>
-              </a:rPr>
-              <a:t> song</a:t>
+              <a:t> cố</a:t>
+            </a:r>
+            <a:r>
+              <a:rPr lang="en-US" sz="2250" b="1" dirty="0" spc="15" kern="0">
+                <a:solidFill>
+                  <a:srgbClr val="14161C"/>
+                </a:solidFill>
+                <a:latin typeface="Be Vietnam Pro" pitchFamily="34" charset="0"/>
+                <a:ea typeface="Be Vietnam Pro" pitchFamily="34" charset="-122"/>
+                <a:cs typeface="Be Vietnam Pro" pitchFamily="34" charset="-120"/>
+              </a:rPr>
+              <a:t> định</a:t>
             </a:r>
             <a:endParaRPr lang="en-US" sz="2250" dirty="0"/>
           </a:p>
@@ -16151,48 +16305,48 @@
               <a:buNone/>
             </a:pPr>
             <a:r>
-              <a:rPr lang="en-US" sz="2250" b="1" dirty="0" spc="-6" kern="0">
-                <a:solidFill>
-                  <a:srgbClr val="14161C"/>
-                </a:solidFill>
-                <a:latin typeface="Be Vietnam Pro" pitchFamily="34" charset="0"/>
-                <a:ea typeface="Be Vietnam Pro" pitchFamily="34" charset="-122"/>
-                <a:cs typeface="Be Vietnam Pro" pitchFamily="34" charset="-120"/>
-              </a:rPr>
-              <a:t>sang</a:t>
-            </a:r>
-            <a:r>
-              <a:rPr lang="en-US" sz="2250" b="1" dirty="0" spc="4" kern="0">
-                <a:solidFill>
-                  <a:srgbClr val="14161C"/>
-                </a:solidFill>
-                <a:latin typeface="Be Vietnam Pro" pitchFamily="34" charset="0"/>
-                <a:ea typeface="Be Vietnam Pro" pitchFamily="34" charset="-122"/>
-                <a:cs typeface="Be Vietnam Pro" pitchFamily="34" charset="-120"/>
-              </a:rPr>
-              <a:t> giai</a:t>
-            </a:r>
-            <a:r>
-              <a:rPr lang="en-US" sz="2250" b="1" dirty="0" spc="5" kern="0">
-                <a:solidFill>
-                  <a:srgbClr val="14161C"/>
-                </a:solidFill>
-                <a:latin typeface="Be Vietnam Pro" pitchFamily="34" charset="0"/>
-                <a:ea typeface="Be Vietnam Pro" pitchFamily="34" charset="-122"/>
-                <a:cs typeface="Be Vietnam Pro" pitchFamily="34" charset="-120"/>
-              </a:rPr>
-              <a:t> đoạn</a:t>
-            </a:r>
-            <a:r>
-              <a:rPr lang="en-US" sz="2250" b="1" dirty="0" spc="-27" kern="0">
-                <a:solidFill>
-                  <a:srgbClr val="14161C"/>
-                </a:solidFill>
-                <a:latin typeface="Be Vietnam Pro" pitchFamily="34" charset="0"/>
-                <a:ea typeface="Be Vietnam Pro" pitchFamily="34" charset="-122"/>
-                <a:cs typeface="Be Vietnam Pro" pitchFamily="34" charset="-120"/>
-              </a:rPr>
-              <a:t> kế</a:t>
+              <a:rPr lang="en-US" sz="2250" b="1" dirty="0" spc="-4" kern="0">
+                <a:solidFill>
+                  <a:srgbClr val="14161C"/>
+                </a:solidFill>
+                <a:latin typeface="Be Vietnam Pro" pitchFamily="34" charset="0"/>
+                <a:ea typeface="Be Vietnam Pro" pitchFamily="34" charset="-122"/>
+                <a:cs typeface="Be Vietnam Pro" pitchFamily="34" charset="-120"/>
+              </a:rPr>
+              <a:t>dùng</a:t>
+            </a:r>
+            <a:r>
+              <a:rPr lang="en-US" sz="2250" b="1" dirty="0" spc="1" kern="0">
+                <a:solidFill>
+                  <a:srgbClr val="14161C"/>
+                </a:solidFill>
+                <a:latin typeface="Be Vietnam Pro" pitchFamily="34" charset="0"/>
+                <a:ea typeface="Be Vietnam Pro" pitchFamily="34" charset="-122"/>
+                <a:cs typeface="Be Vietnam Pro" pitchFamily="34" charset="-120"/>
+              </a:rPr>
+              <a:t> lại</a:t>
+            </a:r>
+            <a:r>
+              <a:rPr lang="en-US" sz="2250" b="1" dirty="0" spc="2" kern="0">
+                <a:solidFill>
+                  <a:srgbClr val="14161C"/>
+                </a:solidFill>
+                <a:latin typeface="Be Vietnam Pro" pitchFamily="34" charset="0"/>
+                <a:ea typeface="Be Vietnam Pro" pitchFamily="34" charset="-122"/>
+                <a:cs typeface="Be Vietnam Pro" pitchFamily="34" charset="-120"/>
+              </a:rPr>
+              <a:t> nhiều</a:t>
+            </a:r>
+            <a:r>
+              <a:rPr lang="en-US" sz="2250" b="1" dirty="0" spc="-2" kern="0">
+                <a:solidFill>
+                  <a:srgbClr val="14161C"/>
+                </a:solidFill>
+                <a:latin typeface="Be Vietnam Pro" pitchFamily="34" charset="0"/>
+                <a:ea typeface="Be Vietnam Pro" pitchFamily="34" charset="-122"/>
+                <a:cs typeface="Be Vietnam Pro" pitchFamily="34" charset="-120"/>
+              </a:rPr>
+              <a:t> lần</a:t>
             </a:r>
             <a:endParaRPr lang="en-US" sz="2250" dirty="0"/>
           </a:p>
@@ -16298,6 +16452,39 @@
               <a:buNone/>
             </a:pPr>
             <a:r>
+              <a:rPr lang="en-US" sz="2700" dirty="0" spc="-1" kern="0">
+                <a:solidFill>
+                  <a:srgbClr val="F3EEE3"/>
+                </a:solidFill>
+                <a:latin typeface="Be Vietnam Pro" pitchFamily="34" charset="0"/>
+                <a:ea typeface="Be Vietnam Pro" pitchFamily="34" charset="-122"/>
+                <a:cs typeface="Be Vietnam Pro" pitchFamily="34" charset="-120"/>
+              </a:rPr>
+              <a:t>Đủ</a:t>
+            </a:r>
+            <a:r>
+              <a:rPr lang="en-US" sz="2700" dirty="0" spc="-13" kern="0">
+                <a:solidFill>
+                  <a:srgbClr val="F3EEE3"/>
+                </a:solidFill>
+                <a:latin typeface="Be Vietnam Pro" pitchFamily="34" charset="0"/>
+                <a:ea typeface="Be Vietnam Pro" pitchFamily="34" charset="-122"/>
+                <a:cs typeface="Be Vietnam Pro" pitchFamily="34" charset="-120"/>
+              </a:rPr>
+              <a:t> mặt</a:t>
+            </a:r>
+            <a:r>
+              <a:rPr lang="en-US" sz="2700" dirty="0" spc="-1" kern="0">
+                <a:solidFill>
+                  <a:srgbClr val="F3EEE3"/>
+                </a:solidFill>
+                <a:latin typeface="Be Vietnam Pro" pitchFamily="34" charset="0"/>
+                <a:ea typeface="Be Vietnam Pro" pitchFamily="34" charset="-122"/>
+                <a:cs typeface="Be Vietnam Pro" pitchFamily="34" charset="-120"/>
+              </a:rPr>
+              <a:t> thì</a:t>
+            </a:r>
+            <a:r>
               <a:rPr lang="en-US" sz="2700" dirty="0" spc="0" kern="0">
                 <a:solidFill>
                   <a:srgbClr val="F3EEE3"/>
@@ -16306,7 +16493,7 @@
                 <a:ea typeface="Be Vietnam Pro" pitchFamily="34" charset="-122"/>
                 <a:cs typeface="Be Vietnam Pro" pitchFamily="34" charset="-120"/>
               </a:rPr>
-              <a:t>Mọi</a:t>
+              <a:t> thả</a:t>
             </a:r>
             <a:r>
               <a:rPr lang="en-US" sz="2700" dirty="0" spc="-1" kern="0">
@@ -16317,18 +16504,18 @@
                 <a:ea typeface="Be Vietnam Pro" pitchFamily="34" charset="-122"/>
                 <a:cs typeface="Be Vietnam Pro" pitchFamily="34" charset="-120"/>
               </a:rPr>
-              <a:t> luồng cùng</a:t>
-            </a:r>
-            <a:r>
-              <a:rPr lang="en-US" sz="2700" dirty="0" spc="-14" kern="0">
-                <a:solidFill>
-                  <a:srgbClr val="F3EEE3"/>
-                </a:solidFill>
-                <a:latin typeface="Be Vietnam Pro" pitchFamily="34" charset="0"/>
-                <a:ea typeface="Be Vietnam Pro" pitchFamily="34" charset="-122"/>
-                <a:cs typeface="Be Vietnam Pro" pitchFamily="34" charset="-120"/>
-              </a:rPr>
-              <a:t> tới</a:t>
+              <a:t> cùng</a:t>
+            </a:r>
+            <a:r>
+              <a:rPr lang="en-US" sz="2700" dirty="0" spc="0" kern="0">
+                <a:solidFill>
+                  <a:srgbClr val="F3EEE3"/>
+                </a:solidFill>
+                <a:latin typeface="Be Vietnam Pro" pitchFamily="34" charset="0"/>
+                <a:ea typeface="Be Vietnam Pro" pitchFamily="34" charset="-122"/>
+                <a:cs typeface="Be Vietnam Pro" pitchFamily="34" charset="-120"/>
+              </a:rPr>
+              <a:t> lúc;</a:t>
             </a:r>
             <a:r>
               <a:rPr lang="en-US" sz="2700" dirty="0" spc="-30" kern="0">
@@ -16342,6 +16529,28 @@
               <a:t> rào</a:t>
             </a:r>
             <a:r>
+              <a:rPr lang="en-US" sz="2700" dirty="0" spc="-3" kern="0">
+                <a:solidFill>
+                  <a:srgbClr val="F3EEE3"/>
+                </a:solidFill>
+                <a:latin typeface="Be Vietnam Pro" pitchFamily="34" charset="0"/>
+                <a:ea typeface="Be Vietnam Pro" pitchFamily="34" charset="-122"/>
+                <a:cs typeface="Be Vietnam Pro" pitchFamily="34" charset="-120"/>
+              </a:rPr>
+              <a:t> dùng</a:t>
+            </a:r>
+            <a:r>
+              <a:rPr lang="en-US" sz="2700" dirty="0" spc="0" kern="0">
+                <a:solidFill>
+                  <a:srgbClr val="F3EEE3"/>
+                </a:solidFill>
+                <a:latin typeface="Be Vietnam Pro" pitchFamily="34" charset="0"/>
+                <a:ea typeface="Be Vietnam Pro" pitchFamily="34" charset="-122"/>
+                <a:cs typeface="Be Vietnam Pro" pitchFamily="34" charset="-120"/>
+              </a:rPr>
+              <a:t> lại</a:t>
+            </a:r>
+            <a:r>
               <a:rPr lang="en-US" sz="2700" dirty="0" spc="-1" kern="0">
                 <a:solidFill>
                   <a:srgbClr val="F3EEE3"/>
@@ -16350,7 +16559,7 @@
                 <a:ea typeface="Be Vietnam Pro" pitchFamily="34" charset="-122"/>
                 <a:cs typeface="Be Vietnam Pro" pitchFamily="34" charset="-120"/>
               </a:rPr>
-              <a:t> thì</a:t>
+              <a:t> cho</a:t>
             </a:r>
             <a:r>
               <a:rPr lang="en-US" sz="2700" dirty="0" spc="-2" kern="0">
@@ -16361,7 +16570,18 @@
                 <a:ea typeface="Be Vietnam Pro" pitchFamily="34" charset="-122"/>
                 <a:cs typeface="Be Vietnam Pro" pitchFamily="34" charset="-120"/>
               </a:rPr>
-              <a:t> mới</a:t>
+              <a:t> cùng</a:t>
+            </a:r>
+            <a:r>
+              <a:rPr lang="en-US" sz="2700" dirty="0" spc="-11" kern="0">
+                <a:solidFill>
+                  <a:srgbClr val="F3EEE3"/>
+                </a:solidFill>
+                <a:latin typeface="Be Vietnam Pro" pitchFamily="34" charset="0"/>
+                <a:ea typeface="Be Vietnam Pro" pitchFamily="34" charset="-122"/>
+                <a:cs typeface="Be Vietnam Pro" pitchFamily="34" charset="-120"/>
+              </a:rPr>
+              <a:t> số</a:t>
             </a:r>
             <a:r>
               <a:rPr lang="en-US" sz="2700" dirty="0" spc="-1" kern="0">
@@ -16372,29 +16592,7 @@
                 <a:ea typeface="Be Vietnam Pro" pitchFamily="34" charset="-122"/>
                 <a:cs typeface="Be Vietnam Pro" pitchFamily="34" charset="-120"/>
               </a:rPr>
-              <a:t> cùng</a:t>
-            </a:r>
-            <a:r>
-              <a:rPr lang="en-US" sz="2700" dirty="0" spc="34" kern="0">
-                <a:solidFill>
-                  <a:srgbClr val="F3EEE3"/>
-                </a:solidFill>
-                <a:latin typeface="Be Vietnam Pro" pitchFamily="34" charset="0"/>
-                <a:ea typeface="Be Vietnam Pro" pitchFamily="34" charset="-122"/>
-                <a:cs typeface="Be Vietnam Pro" pitchFamily="34" charset="-120"/>
-              </a:rPr>
-              <a:t> đi</a:t>
-            </a:r>
-            <a:r>
-              <a:rPr lang="en-US" sz="2700" dirty="0" spc="-1" kern="0">
-                <a:solidFill>
-                  <a:srgbClr val="F3EEE3"/>
-                </a:solidFill>
-                <a:latin typeface="Be Vietnam Pro" pitchFamily="34" charset="0"/>
-                <a:ea typeface="Be Vietnam Pro" pitchFamily="34" charset="-122"/>
-                <a:cs typeface="Be Vietnam Pro" pitchFamily="34" charset="-120"/>
-              </a:rPr>
-              <a:t> tiếp.</a:t>
+              <a:t> luồng.</a:t>
             </a:r>
             <a:endParaRPr lang="en-US" sz="2700" dirty="0"/>
           </a:p>
@@ -18269,48 +18467,15 @@
               <a:buChar char="•"/>
             </a:pPr>
             <a:r>
-              <a:rPr lang="en-US" sz="2250" dirty="0" spc="-3" kern="0">
-                <a:solidFill>
-                  <a:srgbClr val="14161C"/>
-                </a:solidFill>
-                <a:latin typeface="Be Vietnam Pro" pitchFamily="34" charset="0"/>
-                <a:ea typeface="Be Vietnam Pro" pitchFamily="34" charset="-122"/>
-                <a:cs typeface="Be Vietnam Pro" pitchFamily="34" charset="-120"/>
-              </a:rPr>
-              <a:t>Bài</a:t>
-            </a:r>
-            <a:r>
-              <a:rPr lang="en-US" sz="2250" dirty="0" spc="2" kern="0">
-                <a:solidFill>
-                  <a:srgbClr val="14161C"/>
-                </a:solidFill>
-                <a:latin typeface="Be Vietnam Pro" pitchFamily="34" charset="0"/>
-                <a:ea typeface="Be Vietnam Pro" pitchFamily="34" charset="-122"/>
-                <a:cs typeface="Be Vietnam Pro" pitchFamily="34" charset="-120"/>
-              </a:rPr>
-              <a:t> nguồn</a:t>
-            </a:r>
-            <a:r>
-              <a:rPr lang="en-US" sz="2250" dirty="0" spc="0" kern="0">
-                <a:solidFill>
-                  <a:srgbClr val="14161C"/>
-                </a:solidFill>
-                <a:latin typeface="Be Vietnam Pro" pitchFamily="34" charset="0"/>
-                <a:ea typeface="Be Vietnam Pro" pitchFamily="34" charset="-122"/>
-                <a:cs typeface="Be Vietnam Pro" pitchFamily="34" charset="-120"/>
-              </a:rPr>
-              <a:t> chỉ</a:t>
-            </a:r>
-            <a:r>
-              <a:rPr lang="en-US" sz="2250" dirty="0" spc="3" kern="0">
-                <a:solidFill>
-                  <a:srgbClr val="14161C"/>
-                </a:solidFill>
-                <a:latin typeface="Be Vietnam Pro" pitchFamily="34" charset="0"/>
-                <a:ea typeface="Be Vietnam Pro" pitchFamily="34" charset="-122"/>
-                <a:cs typeface="Be Vietnam Pro" pitchFamily="34" charset="-120"/>
-              </a:rPr>
-              <a:t> mô</a:t>
+              <a:rPr lang="en-US" sz="2250" dirty="0" spc="-1" kern="0">
+                <a:solidFill>
+                  <a:srgbClr val="14161C"/>
+                </a:solidFill>
+                <a:latin typeface="Be Vietnam Pro" pitchFamily="34" charset="0"/>
+                <a:ea typeface="Be Vietnam Pro" pitchFamily="34" charset="-122"/>
+                <a:cs typeface="Be Vietnam Pro" pitchFamily="34" charset="-120"/>
+              </a:rPr>
+              <a:t>Mô</a:t>
             </a:r>
             <a:r>
               <a:rPr lang="en-US" sz="2250" dirty="0" spc="-15" kern="0">
@@ -18324,59 +18489,70 @@
               <a:t> tả</a:t>
             </a:r>
             <a:r>
-              <a:rPr lang="en-US" sz="2250" dirty="0" spc="2" kern="0">
-                <a:solidFill>
-                  <a:srgbClr val="14161C"/>
-                </a:solidFill>
-                <a:latin typeface="Be Vietnam Pro" pitchFamily="34" charset="0"/>
-                <a:ea typeface="Be Vietnam Pro" pitchFamily="34" charset="-122"/>
-                <a:cs typeface="Be Vietnam Pro" pitchFamily="34" charset="-120"/>
-              </a:rPr>
-              <a:t> ý</a:t>
-            </a:r>
-            <a:r>
-              <a:rPr lang="en-US" sz="2250" dirty="0" spc="5" kern="0">
-                <a:solidFill>
-                  <a:srgbClr val="14161C"/>
-                </a:solidFill>
-                <a:latin typeface="Be Vietnam Pro" pitchFamily="34" charset="0"/>
-                <a:ea typeface="Be Vietnam Pro" pitchFamily="34" charset="-122"/>
-                <a:cs typeface="Be Vietnam Pro" pitchFamily="34" charset="-120"/>
-              </a:rPr>
-              <a:t> tưởng,</a:t>
-            </a:r>
-            <a:r>
-              <a:rPr lang="en-US" sz="2250" dirty="0" spc="0" kern="0">
-                <a:solidFill>
-                  <a:srgbClr val="14161C"/>
-                </a:solidFill>
-                <a:latin typeface="Be Vietnam Pro" pitchFamily="34" charset="0"/>
-                <a:ea typeface="Be Vietnam Pro" pitchFamily="34" charset="-122"/>
-                <a:cs typeface="Be Vietnam Pro" pitchFamily="34" charset="-120"/>
-              </a:rPr>
-              <a:t> không</a:t>
-            </a:r>
-            <a:r>
-              <a:rPr lang="en-US" sz="2250" dirty="0" spc="5" kern="0">
-                <a:solidFill>
-                  <a:srgbClr val="14161C"/>
-                </a:solidFill>
-                <a:latin typeface="Be Vietnam Pro" pitchFamily="34" charset="0"/>
-                <a:ea typeface="Be Vietnam Pro" pitchFamily="34" charset="-122"/>
-                <a:cs typeface="Be Vietnam Pro" pitchFamily="34" charset="-120"/>
-              </a:rPr>
-              <a:t> có</a:t>
-            </a:r>
-            <a:r>
-              <a:rPr lang="en-US" sz="2250" dirty="0" spc="-1" kern="0">
-                <a:solidFill>
-                  <a:srgbClr val="14161C"/>
-                </a:solidFill>
-                <a:latin typeface="Be Vietnam Pro" pitchFamily="34" charset="0"/>
-                <a:ea typeface="Be Vietnam Pro" pitchFamily="34" charset="-122"/>
-                <a:cs typeface="Be Vietnam Pro" pitchFamily="34" charset="-120"/>
-              </a:rPr>
-              <a:t> mã</a:t>
+              <a:rPr lang="en-US" sz="2250" dirty="0" spc="1" kern="0">
+                <a:solidFill>
+                  <a:srgbClr val="14161C"/>
+                </a:solidFill>
+                <a:latin typeface="Be Vietnam Pro" pitchFamily="34" charset="0"/>
+                <a:ea typeface="Be Vietnam Pro" pitchFamily="34" charset="-122"/>
+                <a:cs typeface="Be Vietnam Pro" pitchFamily="34" charset="-120"/>
+              </a:rPr>
+              <a:t> cách thư</a:t>
+            </a:r>
+            <a:r>
+              <a:rPr lang="en-US" sz="2250" dirty="0" spc="-2" kern="0">
+                <a:solidFill>
+                  <a:srgbClr val="14161C"/>
+                </a:solidFill>
+                <a:latin typeface="Be Vietnam Pro" pitchFamily="34" charset="0"/>
+                <a:ea typeface="Be Vietnam Pro" pitchFamily="34" charset="-122"/>
+                <a:cs typeface="Be Vietnam Pro" pitchFamily="34" charset="-120"/>
+              </a:rPr>
+              <a:t> viện</a:t>
+            </a:r>
+            <a:r>
+              <a:rPr lang="en-US" sz="2250" dirty="0" spc="6" kern="0">
+                <a:solidFill>
+                  <a:srgbClr val="14161C"/>
+                </a:solidFill>
+                <a:latin typeface="Be Vietnam Pro" pitchFamily="34" charset="0"/>
+                <a:ea typeface="Be Vietnam Pro" pitchFamily="34" charset="-122"/>
+                <a:cs typeface="Be Vietnam Pro" pitchFamily="34" charset="-120"/>
+              </a:rPr>
+              <a:t> Python</a:t>
+            </a:r>
+            <a:r>
+              <a:rPr lang="en-US" sz="2250" dirty="0" spc="-15" kern="0">
+                <a:solidFill>
+                  <a:srgbClr val="14161C"/>
+                </a:solidFill>
+                <a:latin typeface="Be Vietnam Pro" pitchFamily="34" charset="0"/>
+                <a:ea typeface="Be Vietnam Pro" pitchFamily="34" charset="-122"/>
+                <a:cs typeface="Be Vietnam Pro" pitchFamily="34" charset="-120"/>
+              </a:rPr>
+              <a:t> và</a:t>
+            </a:r>
+            <a:r>
+              <a:rPr lang="en-US" sz="2250" dirty="0" spc="1" kern="0">
+                <a:solidFill>
+                  <a:srgbClr val="14161C"/>
+                </a:solidFill>
+                <a:latin typeface="Be Vietnam Pro" pitchFamily="34" charset="0"/>
+                <a:ea typeface="Be Vietnam Pro" pitchFamily="34" charset="-122"/>
+                <a:cs typeface="Be Vietnam Pro" pitchFamily="34" charset="-120"/>
+              </a:rPr>
+              <a:t> JDK</a:t>
+            </a:r>
+            <a:r>
+              <a:rPr lang="en-US" sz="2250" dirty="0" spc="-2" kern="0">
+                <a:solidFill>
+                  <a:srgbClr val="14161C"/>
+                </a:solidFill>
+                <a:latin typeface="Be Vietnam Pro" pitchFamily="34" charset="0"/>
+                <a:ea typeface="Be Vietnam Pro" pitchFamily="34" charset="-122"/>
+                <a:cs typeface="Be Vietnam Pro" pitchFamily="34" charset="-120"/>
+              </a:rPr>
+              <a:t> làm</a:t>
             </a:r>
             <a:endParaRPr lang="en-US" sz="2250" dirty="0"/>
           </a:p>
@@ -18393,37 +18569,26 @@
               <a:buChar char="•"/>
             </a:pPr>
             <a:r>
-              <a:rPr lang="en-US" sz="2250" dirty="0" spc="1" kern="0">
-                <a:solidFill>
-                  <a:srgbClr val="14161C"/>
-                </a:solidFill>
-                <a:latin typeface="Be Vietnam Pro" pitchFamily="34" charset="0"/>
-                <a:ea typeface="Be Vietnam Pro" pitchFamily="34" charset="-122"/>
-                <a:cs typeface="Be Vietnam Pro" pitchFamily="34" charset="-120"/>
-              </a:rPr>
-              <a:t>Không</a:t>
-            </a:r>
-            <a:r>
-              <a:rPr lang="en-US" sz="2250" dirty="0" spc="-6" kern="0">
-                <a:solidFill>
-                  <a:srgbClr val="14161C"/>
-                </a:solidFill>
-                <a:latin typeface="Be Vietnam Pro" pitchFamily="34" charset="0"/>
-                <a:ea typeface="Be Vietnam Pro" pitchFamily="34" charset="-122"/>
-                <a:cs typeface="Be Vietnam Pro" pitchFamily="34" charset="-120"/>
-              </a:rPr>
-              <a:t> so</a:t>
-            </a:r>
-            <a:r>
-              <a:rPr lang="en-US" sz="2250" dirty="0" spc="-3" kern="0">
-                <a:solidFill>
-                  <a:srgbClr val="14161C"/>
-                </a:solidFill>
-                <a:latin typeface="Be Vietnam Pro" pitchFamily="34" charset="0"/>
-                <a:ea typeface="Be Vietnam Pro" pitchFamily="34" charset="-122"/>
-                <a:cs typeface="Be Vietnam Pro" pitchFamily="34" charset="-120"/>
-              </a:rPr>
-              <a:t> sánh</a:t>
+              <a:rPr lang="en-US" sz="2250" dirty="0" spc="-11" kern="0">
+                <a:solidFill>
+                  <a:srgbClr val="14161C"/>
+                </a:solidFill>
+                <a:latin typeface="Be Vietnam Pro" pitchFamily="34" charset="0"/>
+                <a:ea typeface="Be Vietnam Pro" pitchFamily="34" charset="-122"/>
+                <a:cs typeface="Be Vietnam Pro" pitchFamily="34" charset="-120"/>
+              </a:rPr>
+              <a:t>Ngôn</a:t>
+            </a:r>
+            <a:r>
+              <a:rPr lang="en-US" sz="2250" dirty="0" spc="2" kern="0">
+                <a:solidFill>
+                  <a:srgbClr val="14161C"/>
+                </a:solidFill>
+                <a:latin typeface="Be Vietnam Pro" pitchFamily="34" charset="0"/>
+                <a:ea typeface="Be Vietnam Pro" pitchFamily="34" charset="-122"/>
+                <a:cs typeface="Be Vietnam Pro" pitchFamily="34" charset="-120"/>
+              </a:rPr>
+              <a:t> ngữ</a:t>
             </a:r>
             <a:r>
               <a:rPr lang="en-US" sz="2250" dirty="0" spc="0" kern="0">
@@ -18434,40 +18599,29 @@
                 <a:ea typeface="Be Vietnam Pro" pitchFamily="34" charset="-122"/>
                 <a:cs typeface="Be Vietnam Pro" pitchFamily="34" charset="-120"/>
               </a:rPr>
-              <a:t> chi</a:t>
-            </a:r>
-            <a:r>
-              <a:rPr lang="en-US" sz="2250" dirty="0" spc="1" kern="0">
-                <a:solidFill>
-                  <a:srgbClr val="14161C"/>
-                </a:solidFill>
-                <a:latin typeface="Be Vietnam Pro" pitchFamily="34" charset="0"/>
-                <a:ea typeface="Be Vietnam Pro" pitchFamily="34" charset="-122"/>
-                <a:cs typeface="Be Vietnam Pro" pitchFamily="34" charset="-120"/>
-              </a:rPr>
-              <a:t> phí</a:t>
-            </a:r>
-            <a:r>
-              <a:rPr lang="en-US" sz="2250" dirty="0" spc="6" kern="0">
-                <a:solidFill>
-                  <a:srgbClr val="14161C"/>
-                </a:solidFill>
-                <a:latin typeface="Be Vietnam Pro" pitchFamily="34" charset="0"/>
-                <a:ea typeface="Be Vietnam Pro" pitchFamily="34" charset="-122"/>
-                <a:cs typeface="Be Vietnam Pro" pitchFamily="34" charset="-120"/>
-              </a:rPr>
-              <a:t> giữa</a:t>
-            </a:r>
-            <a:r>
-              <a:rPr lang="en-US" sz="2250" dirty="0" spc="2" kern="0">
-                <a:solidFill>
-                  <a:srgbClr val="14161C"/>
-                </a:solidFill>
-                <a:latin typeface="Be Vietnam Pro" pitchFamily="34" charset="0"/>
-                <a:ea typeface="Be Vietnam Pro" pitchFamily="34" charset="-122"/>
-                <a:cs typeface="Be Vietnam Pro" pitchFamily="34" charset="-120"/>
-              </a:rPr>
-              <a:t> các</a:t>
+              <a:t> khác</a:t>
+            </a:r>
+            <a:r>
+              <a:rPr lang="en-US" sz="2250" dirty="0" spc="5" kern="0">
+                <a:solidFill>
+                  <a:srgbClr val="14161C"/>
+                </a:solidFill>
+                <a:latin typeface="Be Vietnam Pro" pitchFamily="34" charset="0"/>
+                <a:ea typeface="Be Vietnam Pro" pitchFamily="34" charset="-122"/>
+                <a:cs typeface="Be Vietnam Pro" pitchFamily="34" charset="-120"/>
+              </a:rPr>
+              <a:t> có</a:t>
+            </a:r>
+            <a:r>
+              <a:rPr lang="en-US" sz="2250" dirty="0" spc="0" kern="0">
+                <a:solidFill>
+                  <a:srgbClr val="14161C"/>
+                </a:solidFill>
+                <a:latin typeface="Be Vietnam Pro" pitchFamily="34" charset="0"/>
+                <a:ea typeface="Be Vietnam Pro" pitchFamily="34" charset="-122"/>
+                <a:cs typeface="Be Vietnam Pro" pitchFamily="34" charset="-120"/>
+              </a:rPr>
+              <a:t> thể</a:t>
             </a:r>
             <a:r>
               <a:rPr lang="en-US" sz="2250" dirty="0" spc="-1" kern="0">
@@ -18478,7 +18632,18 @@
                 <a:ea typeface="Be Vietnam Pro" pitchFamily="34" charset="-122"/>
                 <a:cs typeface="Be Vietnam Pro" pitchFamily="34" charset="-120"/>
               </a:rPr>
-              <a:t> mẫu</a:t>
+              <a:t> làm</a:t>
+            </a:r>
+            <a:r>
+              <a:rPr lang="en-US" sz="2250" dirty="0" spc="0" kern="0">
+                <a:solidFill>
+                  <a:srgbClr val="14161C"/>
+                </a:solidFill>
+                <a:latin typeface="Be Vietnam Pro" pitchFamily="34" charset="0"/>
+                <a:ea typeface="Be Vietnam Pro" pitchFamily="34" charset="-122"/>
+                <a:cs typeface="Be Vietnam Pro" pitchFamily="34" charset="-120"/>
+              </a:rPr>
+              <a:t> khác</a:t>
             </a:r>
             <a:endParaRPr lang="en-US" sz="2250" dirty="0"/>
           </a:p>
@@ -18500,7 +18665,29 @@
                 <a:ea typeface="Be Vietnam Pro" pitchFamily="34" charset="-122"/>
                 <a:cs typeface="Be Vietnam Pro" pitchFamily="34" charset="-120"/>
               </a:rPr>
-              <a:t>Không nói</a:t>
+              <a:t>Không</a:t>
+            </a:r>
+            <a:r>
+              <a:rPr lang="en-US" sz="2250" dirty="0" spc="-6" kern="0">
+                <a:solidFill>
+                  <a:srgbClr val="14161C"/>
+                </a:solidFill>
+                <a:latin typeface="Be Vietnam Pro" pitchFamily="34" charset="0"/>
+                <a:ea typeface="Be Vietnam Pro" pitchFamily="34" charset="-122"/>
+                <a:cs typeface="Be Vietnam Pro" pitchFamily="34" charset="-120"/>
+              </a:rPr>
+              <a:t> so</a:t>
+            </a:r>
+            <a:r>
+              <a:rPr lang="en-US" sz="2250" dirty="0" spc="-3" kern="0">
+                <a:solidFill>
+                  <a:srgbClr val="14161C"/>
+                </a:solidFill>
+                <a:latin typeface="Be Vietnam Pro" pitchFamily="34" charset="0"/>
+                <a:ea typeface="Be Vietnam Pro" pitchFamily="34" charset="-122"/>
+                <a:cs typeface="Be Vietnam Pro" pitchFamily="34" charset="-120"/>
+              </a:rPr>
+              <a:t> sánh</a:t>
             </a:r>
             <a:r>
               <a:rPr lang="en-US" sz="2250" dirty="0" spc="0" kern="0">
@@ -18511,18 +18698,40 @@
                 <a:ea typeface="Be Vietnam Pro" pitchFamily="34" charset="-122"/>
                 <a:cs typeface="Be Vietnam Pro" pitchFamily="34" charset="-120"/>
               </a:rPr>
-              <a:t> khi</a:t>
-            </a:r>
-            <a:r>
-              <a:rPr lang="en-US" sz="2250" dirty="0" spc="-2" kern="0">
-                <a:solidFill>
-                  <a:srgbClr val="14161C"/>
-                </a:solidFill>
-                <a:latin typeface="Be Vietnam Pro" pitchFamily="34" charset="0"/>
-                <a:ea typeface="Be Vietnam Pro" pitchFamily="34" charset="-122"/>
-                <a:cs typeface="Be Vietnam Pro" pitchFamily="34" charset="-120"/>
-              </a:rPr>
-              <a:t> nào</a:t>
+              <a:t> chi</a:t>
+            </a:r>
+            <a:r>
+              <a:rPr lang="en-US" sz="2250" dirty="0" spc="1" kern="0">
+                <a:solidFill>
+                  <a:srgbClr val="14161C"/>
+                </a:solidFill>
+                <a:latin typeface="Be Vietnam Pro" pitchFamily="34" charset="0"/>
+                <a:ea typeface="Be Vietnam Pro" pitchFamily="34" charset="-122"/>
+                <a:cs typeface="Be Vietnam Pro" pitchFamily="34" charset="-120"/>
+              </a:rPr>
+              <a:t> phí</a:t>
+            </a:r>
+            <a:r>
+              <a:rPr lang="en-US" sz="2250" dirty="0" spc="6" kern="0">
+                <a:solidFill>
+                  <a:srgbClr val="14161C"/>
+                </a:solidFill>
+                <a:latin typeface="Be Vietnam Pro" pitchFamily="34" charset="0"/>
+                <a:ea typeface="Be Vietnam Pro" pitchFamily="34" charset="-122"/>
+                <a:cs typeface="Be Vietnam Pro" pitchFamily="34" charset="-120"/>
+              </a:rPr>
+              <a:t> giữa</a:t>
+            </a:r>
+            <a:r>
+              <a:rPr lang="en-US" sz="2250" dirty="0" spc="2" kern="0">
+                <a:solidFill>
+                  <a:srgbClr val="14161C"/>
+                </a:solidFill>
+                <a:latin typeface="Be Vietnam Pro" pitchFamily="34" charset="0"/>
+                <a:ea typeface="Be Vietnam Pro" pitchFamily="34" charset="-122"/>
+                <a:cs typeface="Be Vietnam Pro" pitchFamily="34" charset="-120"/>
+              </a:rPr>
+              <a:t> các</a:t>
             </a:r>
             <a:r>
               <a:rPr lang="en-US" sz="2250" dirty="0" spc="-1" kern="0">
@@ -18534,39 +18743,6 @@
                 <a:cs typeface="Be Vietnam Pro" pitchFamily="34" charset="-120"/>
               </a:rPr>
               <a:t> mẫu</a:t>
-            </a:r>
-            <a:r>
-              <a:rPr lang="en-US" sz="2250" dirty="0" spc="-8" kern="0">
-                <a:solidFill>
-                  <a:srgbClr val="14161C"/>
-                </a:solidFill>
-                <a:latin typeface="Be Vietnam Pro" pitchFamily="34" charset="0"/>
-                <a:ea typeface="Be Vietnam Pro" pitchFamily="34" charset="-122"/>
-                <a:cs typeface="Be Vietnam Pro" pitchFamily="34" charset="-120"/>
-              </a:rPr>
-              <a:t> này</a:t>
-            </a:r>
-            <a:r>
-              <a:rPr lang="en-US" sz="2250" dirty="0" spc="0" kern="0">
-                <a:solidFill>
-                  <a:srgbClr val="14161C"/>
-                </a:solidFill>
-                <a:latin typeface="Be Vietnam Pro" pitchFamily="34" charset="0"/>
-                <a:ea typeface="Be Vietnam Pro" pitchFamily="34" charset="-122"/>
-                <a:cs typeface="Be Vietnam Pro" pitchFamily="34" charset="-120"/>
-              </a:rPr>
-              <a:t> hơn</a:t>
-            </a:r>
-            <a:r>
-              <a:rPr lang="en-US" sz="2250" dirty="0" spc="-2" kern="0">
-                <a:solidFill>
-                  <a:srgbClr val="14161C"/>
-                </a:solidFill>
-                <a:latin typeface="Be Vietnam Pro" pitchFamily="34" charset="0"/>
-                <a:ea typeface="Be Vietnam Pro" pitchFamily="34" charset="-122"/>
-                <a:cs typeface="Be Vietnam Pro" pitchFamily="34" charset="-120"/>
-              </a:rPr>
-              <a:t> mẫu kia</a:t>
             </a:r>
             <a:endParaRPr lang="en-US" sz="2250" dirty="0"/>
           </a:p>

</xml_diff>